<commit_message>
Slides vulnerabilites : formulation simplifiee
Titres en francais courant, jargon retire du corps des cartes, code
technique conserve en petit. Recap reformule (on entre / on commande /
personne ne voit / ca explose).

Co-Authored-By: Claude Opus 5 <noreply@anthropic.com>
Claude-Session: https://claude.ai/code/session_01KhTm6BJigzmSeGC1HemtWU
</commit_message>
<xml_diff>
--- a/Vulnerabilites_slides.pptx
+++ b/Vulnerabilites_slides.pptx
@@ -504,7 +504,7 @@
           <a:p>
             <a:r>
               <a:rPr lang="en-US" dirty="0"/>
-              <a:t>Les vulnérabilités physiques : 5 failles repérées en visitant l'usine. C'est là que notre attaque a réellement commencé — on a ramassé les mots de passe du routeur et de l'automate à la main, avant toute manipulation réseau. La plupart de ces points relèvent du comportement, donc le correctif le plus efficace et le moins cher, c'est la formation et la sensibilisation.</a:t>
+              <a:t>Les failles physiques : cinq problèmes repérés simplement en visitant l'usine, sans toucher à un ordinateur. C'est là que notre attaque a vraiment commencé — on a récupéré les mots de passe du routeur et de l'automate à la main. Presque tout relève de l'habitude et non de la technique : la meilleure parade, c'est donc la formation des équipes.</a:t>
             </a:r>
             <a:endParaRPr lang="en-US" dirty="0"/>
           </a:p>
@@ -592,7 +592,7 @@
           <a:p>
             <a:r>
               <a:rPr lang="en-US" dirty="0"/>
-              <a:t>Côté cyber, on ne garde que 4 failles, les plus déterminantes. V1 le pare-feu ouvert et V3 le Modbus sans authentification permettent d'aller librement jusqu'à l'automate. V7-V8, l'absence de détection, fait que l'attaque passe inaperçue. Et V12, l'absence de barrière de sécurité physique indépendante, c'est ce qui transforme la prise de contrôle en explosion. Chaque carte donne le problème, l'effet, et le correctif en vert.</a:t>
+              <a:t>Les quatre failles informatiques, expliquées simplement. Le filtre entre les bureaux et l'usine laisse tout passer — c'est le pare-feu ouvert. Les ordres envoyés aux machines ne sont pas vérifiés — c'est le Modbus sans authentification : n'importe qui peut commander une vanne. Personne ne surveille et rien n'est enregistré — donc l'attaque passe inaperçue. Et surtout : rien n'arrête le réacteur si l'automate est piraté, puisque la seule protection est justement le programme qu'on a modifié. Sur chaque carte, la ligne verte donne le correctif.</a:t>
             </a:r>
             <a:endParaRPr lang="en-US" dirty="0"/>
           </a:p>
@@ -680,7 +680,7 @@
           <a:p>
             <a:r>
               <a:rPr lang="en-US" dirty="0"/>
-              <a:t>Pour retenir : la chaîne se lit en une phrase. Les failles physiques donnent l'accès et les mots de passe. Le pare-feu ouvert et le Modbus en clair mènent librement à l'automate. L'absence de détection laisse l'attaque passer inaperçue. Et l'absence de barrière transforme la prise de contrôle en explosion. Message clé : couper un seul maillon casse l'attaque, et la barrière V12 reste le dernier rempart même si tout le reste tombe.</a:t>
+              <a:t>Pour retenir : l'enchaînement se lit en une phrase. Les failles physiques donnent l'accès et les mots de passe. Le filtre ouvert et les ordres non vérifiés mènent jusqu'à l'automate. L'absence de surveillance fait que l'attaque passe inaperçue. Et l'absence de sécurité indépendante transforme la prise de contrôle en explosion. Message clé : couper un seul de ces maillons suffit à faire échouer l'attaque, et la sécurité câblée reste le dernier rempart même si tout le reste tombe.</a:t>
             </a:r>
             <a:endParaRPr lang="en-US" dirty="0"/>
           </a:p>
@@ -1120,7 +1120,7 @@
                 <a:ea typeface="Calibri" pitchFamily="34" charset="-122"/>
                 <a:cs typeface="Calibri" pitchFamily="34" charset="-120"/>
               </a:rPr>
-              <a:t>   ANALYSE DES VULNÉRABILITÉS — PHYSIQUES</a:t>
+              <a:t>   LES FAILLES PHYSIQUES — CE QU'ON TROUVE EN SE PROMENANT</a:t>
             </a:r>
             <a:endParaRPr lang="en-US" sz="1100" dirty="0"/>
           </a:p>
@@ -1162,7 +1162,7 @@
                 <a:ea typeface="Cambria" pitchFamily="34" charset="-122"/>
                 <a:cs typeface="Cambria" pitchFamily="34" charset="-120"/>
               </a:rPr>
-              <a:t>5 failles trouvées en se promenant dans l'usine</a:t>
+              <a:t>5 failles trouvées sans toucher à un ordinateur</a:t>
             </a:r>
             <a:endParaRPr lang="en-US" sz="3200" dirty="0"/>
           </a:p>
@@ -1243,7 +1243,7 @@
         <p:spPr>
           <a:xfrm>
             <a:off x="1280160" y="1874520"/>
-            <a:ext cx="6035040" cy="822960"/>
+            <a:ext cx="4480560" cy="822960"/>
           </a:xfrm>
           <a:prstGeom prst="rect">
             <a:avLst/>
@@ -1259,7 +1259,7 @@
               <a:buNone/>
             </a:pPr>
             <a:r>
-              <a:rPr lang="en-US" sz="1500" dirty="0">
+              <a:rPr lang="en-US" sz="1450" dirty="0">
                 <a:solidFill>
                   <a:srgbClr val="ECF1F5"/>
                 </a:solidFill>
@@ -1267,21 +1267,60 @@
                 <a:ea typeface="Calibri" pitchFamily="34" charset="-122"/>
                 <a:cs typeface="Calibri" pitchFamily="34" charset="-120"/>
               </a:rPr>
-              <a:t>Porte à badge maintenue ouverte par un parpaing</a:t>
-            </a:r>
-            <a:endParaRPr lang="en-US" sz="1500" dirty="0"/>
-          </a:p>
-        </p:txBody>
-      </p:sp>
-      <p:sp>
-        <p:nvSpPr>
-          <p:cNvPr id="8" name="Shape 6"/>
+              <a:t>Une porte à badge calée ouverte avec un parpaing</a:t>
+            </a:r>
+            <a:endParaRPr lang="en-US" sz="1450" dirty="0"/>
+          </a:p>
+        </p:txBody>
+      </p:sp>
+      <p:sp>
+        <p:nvSpPr>
+          <p:cNvPr id="8" name="Text 6"/>
+          <p:cNvSpPr txBox="1"/>
+          <p:nvPr/>
+        </p:nvSpPr>
+        <p:spPr>
+          <a:xfrm>
+            <a:off x="5852160" y="1874520"/>
+            <a:ext cx="2651760" cy="822960"/>
+          </a:xfrm>
+          <a:prstGeom prst="rect">
+            <a:avLst/>
+          </a:prstGeom>
+          <a:noFill/>
+          <a:ln/>
+        </p:spPr>
+        <p:txBody>
+          <a:bodyPr wrap="square" lIns="0" tIns="0" rIns="0" bIns="0" rtlCol="0" anchor="ctr"/>
+          <a:lstStyle/>
+          <a:p>
+            <a:pPr indent="0" marL="0">
+              <a:buNone/>
+            </a:pPr>
+            <a:r>
+              <a:rPr lang="en-US" sz="1250" dirty="0">
+                <a:solidFill>
+                  <a:srgbClr val="9DABB6"/>
+                </a:solidFill>
+                <a:latin typeface="Calibri" pitchFamily="34" charset="0"/>
+                <a:ea typeface="Calibri" pitchFamily="34" charset="-122"/>
+                <a:cs typeface="Calibri" pitchFamily="34" charset="-120"/>
+              </a:rPr>
+              <a:t>→  On entre sans badge</a:t>
+            </a:r>
+            <a:endParaRPr lang="en-US" sz="1250" dirty="0"/>
+          </a:p>
+        </p:txBody>
+      </p:sp>
+      <p:sp>
+        <p:nvSpPr>
+          <p:cNvPr id="9" name="Shape 7"/>
           <p:cNvSpPr/>
           <p:nvPr/>
         </p:nvSpPr>
         <p:spPr>
           <a:xfrm>
-            <a:off x="7452360" y="2020824"/>
+            <a:off x="8641080" y="2020824"/>
             <a:ext cx="0" cy="530352"/>
           </a:xfrm>
           <a:prstGeom prst="line">
@@ -1298,14 +1337,14 @@
       </p:sp>
       <p:sp>
         <p:nvSpPr>
-          <p:cNvPr id="9" name="Text 7"/>
-          <p:cNvSpPr txBox="1"/>
-          <p:nvPr/>
-        </p:nvSpPr>
-        <p:spPr>
-          <a:xfrm>
-            <a:off x="7635240" y="1874520"/>
-            <a:ext cx="3977640" cy="822960"/>
+          <p:cNvPr id="10" name="Text 8"/>
+          <p:cNvSpPr txBox="1"/>
+          <p:nvPr/>
+        </p:nvSpPr>
+        <p:spPr>
+          <a:xfrm>
+            <a:off x="8823960" y="1874520"/>
+            <a:ext cx="2788920" cy="822960"/>
           </a:xfrm>
           <a:prstGeom prst="rect">
             <a:avLst/>
@@ -1321,7 +1360,7 @@
               <a:buNone/>
             </a:pPr>
             <a:r>
-              <a:rPr lang="en-US" sz="1350" b="1" dirty="0">
+              <a:rPr lang="en-US" sz="1200" dirty="0">
                 <a:solidFill>
                   <a:srgbClr val="6FBF95"/>
                 </a:solidFill>
@@ -1329,29 +1368,15 @@
                 <a:ea typeface="Calibri" pitchFamily="34" charset="-122"/>
                 <a:cs typeface="Calibri" pitchFamily="34" charset="-120"/>
               </a:rPr>
-              <a:t>→  </a:t>
-            </a:r>
-            <a:pPr indent="0" marL="0">
-              <a:buNone/>
-            </a:pPr>
-            <a:r>
-              <a:rPr lang="en-US" sz="1350" dirty="0">
-                <a:solidFill>
-                  <a:srgbClr val="6FBF95"/>
-                </a:solidFill>
-                <a:latin typeface="Calibri" pitchFamily="34" charset="0"/>
-                <a:ea typeface="Calibri" pitchFamily="34" charset="-122"/>
-                <a:cs typeface="Calibri" pitchFamily="34" charset="-120"/>
-              </a:rPr>
               <a:t>Ferme-porte + alarme, sensibilisation</a:t>
             </a:r>
-            <a:endParaRPr lang="en-US" sz="1350" dirty="0"/>
-          </a:p>
-        </p:txBody>
-      </p:sp>
-      <p:sp>
-        <p:nvSpPr>
-          <p:cNvPr id="10" name="Shape 8"/>
+            <a:endParaRPr lang="en-US" sz="1200" dirty="0"/>
+          </a:p>
+        </p:txBody>
+      </p:sp>
+      <p:sp>
+        <p:nvSpPr>
+          <p:cNvPr id="11" name="Shape 9"/>
           <p:cNvSpPr/>
           <p:nvPr/>
         </p:nvSpPr>
@@ -1378,7 +1403,7 @@
       </p:sp>
       <p:sp>
         <p:nvSpPr>
-          <p:cNvPr id="11" name="Text 9"/>
+          <p:cNvPr id="12" name="Text 10"/>
           <p:cNvSpPr txBox="1"/>
           <p:nvPr/>
         </p:nvSpPr>
@@ -1417,14 +1442,14 @@
       </p:sp>
       <p:sp>
         <p:nvSpPr>
-          <p:cNvPr id="12" name="Text 10"/>
+          <p:cNvPr id="13" name="Text 11"/>
           <p:cNvSpPr txBox="1"/>
           <p:nvPr/>
         </p:nvSpPr>
         <p:spPr>
           <a:xfrm>
             <a:off x="1280160" y="2807208"/>
-            <a:ext cx="6035040" cy="822960"/>
+            <a:ext cx="4480560" cy="822960"/>
           </a:xfrm>
           <a:prstGeom prst="rect">
             <a:avLst/>
@@ -1440,7 +1465,7 @@
               <a:buNone/>
             </a:pPr>
             <a:r>
-              <a:rPr lang="en-US" sz="1500" dirty="0">
+              <a:rPr lang="en-US" sz="1450" dirty="0">
                 <a:solidFill>
                   <a:srgbClr val="ECF1F5"/>
                 </a:solidFill>
@@ -1448,21 +1473,60 @@
                 <a:ea typeface="Calibri" pitchFamily="34" charset="-122"/>
                 <a:cs typeface="Calibri" pitchFamily="34" charset="-120"/>
               </a:rPr>
-              <a:t>Mots de passe sur post-it (×2)</a:t>
-            </a:r>
-            <a:endParaRPr lang="en-US" sz="1500" dirty="0"/>
-          </a:p>
-        </p:txBody>
-      </p:sp>
-      <p:sp>
-        <p:nvSpPr>
-          <p:cNvPr id="13" name="Shape 11"/>
+              <a:t>Des mots de passe écrits sur des post-it (×2)</a:t>
+            </a:r>
+            <a:endParaRPr lang="en-US" sz="1450" dirty="0"/>
+          </a:p>
+        </p:txBody>
+      </p:sp>
+      <p:sp>
+        <p:nvSpPr>
+          <p:cNvPr id="14" name="Text 12"/>
+          <p:cNvSpPr txBox="1"/>
+          <p:nvPr/>
+        </p:nvSpPr>
+        <p:spPr>
+          <a:xfrm>
+            <a:off x="5852160" y="2807208"/>
+            <a:ext cx="2651760" cy="822960"/>
+          </a:xfrm>
+          <a:prstGeom prst="rect">
+            <a:avLst/>
+          </a:prstGeom>
+          <a:noFill/>
+          <a:ln/>
+        </p:spPr>
+        <p:txBody>
+          <a:bodyPr wrap="square" lIns="0" tIns="0" rIns="0" bIns="0" rtlCol="0" anchor="ctr"/>
+          <a:lstStyle/>
+          <a:p>
+            <a:pPr indent="0" marL="0">
+              <a:buNone/>
+            </a:pPr>
+            <a:r>
+              <a:rPr lang="en-US" sz="1250" dirty="0">
+                <a:solidFill>
+                  <a:srgbClr val="9DABB6"/>
+                </a:solidFill>
+                <a:latin typeface="Calibri" pitchFamily="34" charset="0"/>
+                <a:ea typeface="Calibri" pitchFamily="34" charset="-122"/>
+                <a:cs typeface="Calibri" pitchFamily="34" charset="-120"/>
+              </a:rPr>
+              <a:t>→  On récupère les identifiants</a:t>
+            </a:r>
+            <a:endParaRPr lang="en-US" sz="1250" dirty="0"/>
+          </a:p>
+        </p:txBody>
+      </p:sp>
+      <p:sp>
+        <p:nvSpPr>
+          <p:cNvPr id="15" name="Shape 13"/>
           <p:cNvSpPr/>
           <p:nvPr/>
         </p:nvSpPr>
         <p:spPr>
           <a:xfrm>
-            <a:off x="7452360" y="2953512"/>
+            <a:off x="8641080" y="2953512"/>
             <a:ext cx="0" cy="530352"/>
           </a:xfrm>
           <a:prstGeom prst="line">
@@ -1479,14 +1543,14 @@
       </p:sp>
       <p:sp>
         <p:nvSpPr>
-          <p:cNvPr id="14" name="Text 12"/>
-          <p:cNvSpPr txBox="1"/>
-          <p:nvPr/>
-        </p:nvSpPr>
-        <p:spPr>
-          <a:xfrm>
-            <a:off x="7635240" y="2807208"/>
-            <a:ext cx="3977640" cy="822960"/>
+          <p:cNvPr id="16" name="Text 14"/>
+          <p:cNvSpPr txBox="1"/>
+          <p:nvPr/>
+        </p:nvSpPr>
+        <p:spPr>
+          <a:xfrm>
+            <a:off x="8823960" y="2807208"/>
+            <a:ext cx="2788920" cy="822960"/>
           </a:xfrm>
           <a:prstGeom prst="rect">
             <a:avLst/>
@@ -1502,7 +1566,7 @@
               <a:buNone/>
             </a:pPr>
             <a:r>
-              <a:rPr lang="en-US" sz="1350" b="1" dirty="0">
+              <a:rPr lang="en-US" sz="1200" dirty="0">
                 <a:solidFill>
                   <a:srgbClr val="6FBF95"/>
                 </a:solidFill>
@@ -1510,29 +1574,15 @@
                 <a:ea typeface="Calibri" pitchFamily="34" charset="-122"/>
                 <a:cs typeface="Calibri" pitchFamily="34" charset="-120"/>
               </a:rPr>
-              <a:t>→  </a:t>
-            </a:r>
-            <a:pPr indent="0" marL="0">
-              <a:buNone/>
-            </a:pPr>
-            <a:r>
-              <a:rPr lang="en-US" sz="1350" dirty="0">
-                <a:solidFill>
-                  <a:srgbClr val="6FBF95"/>
-                </a:solidFill>
-                <a:latin typeface="Calibri" pitchFamily="34" charset="0"/>
-                <a:ea typeface="Calibri" pitchFamily="34" charset="-122"/>
-                <a:cs typeface="Calibri" pitchFamily="34" charset="-120"/>
-              </a:rPr>
-              <a:t>Coffre-fort de mots de passe, « clean desk »</a:t>
-            </a:r>
-            <a:endParaRPr lang="en-US" sz="1350" dirty="0"/>
-          </a:p>
-        </p:txBody>
-      </p:sp>
-      <p:sp>
-        <p:nvSpPr>
-          <p:cNvPr id="15" name="Shape 13"/>
+              <a:t>Coffre-fort de mots de passe, bureau net</a:t>
+            </a:r>
+            <a:endParaRPr lang="en-US" sz="1200" dirty="0"/>
+          </a:p>
+        </p:txBody>
+      </p:sp>
+      <p:sp>
+        <p:nvSpPr>
+          <p:cNvPr id="17" name="Shape 15"/>
           <p:cNvSpPr/>
           <p:nvPr/>
         </p:nvSpPr>
@@ -1559,7 +1609,7 @@
       </p:sp>
       <p:sp>
         <p:nvSpPr>
-          <p:cNvPr id="16" name="Text 14"/>
+          <p:cNvPr id="18" name="Text 16"/>
           <p:cNvSpPr txBox="1"/>
           <p:nvPr/>
         </p:nvSpPr>
@@ -1598,14 +1648,14 @@
       </p:sp>
       <p:sp>
         <p:nvSpPr>
-          <p:cNvPr id="17" name="Text 15"/>
+          <p:cNvPr id="19" name="Text 17"/>
           <p:cNvSpPr txBox="1"/>
           <p:nvPr/>
         </p:nvSpPr>
         <p:spPr>
           <a:xfrm>
             <a:off x="1280160" y="3739896"/>
-            <a:ext cx="6035040" cy="822960"/>
+            <a:ext cx="4480560" cy="822960"/>
           </a:xfrm>
           <a:prstGeom prst="rect">
             <a:avLst/>
@@ -1621,7 +1671,7 @@
               <a:buNone/>
             </a:pPr>
             <a:r>
-              <a:rPr lang="en-US" sz="1500" dirty="0">
+              <a:rPr lang="en-US" sz="1450" dirty="0">
                 <a:solidFill>
                   <a:srgbClr val="ECF1F5"/>
                 </a:solidFill>
@@ -1629,21 +1679,60 @@
                 <a:ea typeface="Calibri" pitchFamily="34" charset="-122"/>
                 <a:cs typeface="Calibri" pitchFamily="34" charset="-120"/>
               </a:rPr>
-              <a:t>Carte d'accès laissée sur le bureau</a:t>
-            </a:r>
-            <a:endParaRPr lang="en-US" sz="1500" dirty="0"/>
-          </a:p>
-        </p:txBody>
-      </p:sp>
-      <p:sp>
-        <p:nvSpPr>
-          <p:cNvPr id="18" name="Shape 16"/>
+              <a:t>Une carte d'accès qui traîne sur un bureau</a:t>
+            </a:r>
+            <a:endParaRPr lang="en-US" sz="1450" dirty="0"/>
+          </a:p>
+        </p:txBody>
+      </p:sp>
+      <p:sp>
+        <p:nvSpPr>
+          <p:cNvPr id="20" name="Text 18"/>
+          <p:cNvSpPr txBox="1"/>
+          <p:nvPr/>
+        </p:nvSpPr>
+        <p:spPr>
+          <a:xfrm>
+            <a:off x="5852160" y="3739896"/>
+            <a:ext cx="2651760" cy="822960"/>
+          </a:xfrm>
+          <a:prstGeom prst="rect">
+            <a:avLst/>
+          </a:prstGeom>
+          <a:noFill/>
+          <a:ln/>
+        </p:spPr>
+        <p:txBody>
+          <a:bodyPr wrap="square" lIns="0" tIns="0" rIns="0" bIns="0" rtlCol="0" anchor="ctr"/>
+          <a:lstStyle/>
+          <a:p>
+            <a:pPr indent="0" marL="0">
+              <a:buNone/>
+            </a:pPr>
+            <a:r>
+              <a:rPr lang="en-US" sz="1250" dirty="0">
+                <a:solidFill>
+                  <a:srgbClr val="9DABB6"/>
+                </a:solidFill>
+                <a:latin typeface="Calibri" pitchFamily="34" charset="0"/>
+                <a:ea typeface="Calibri" pitchFamily="34" charset="-122"/>
+                <a:cs typeface="Calibri" pitchFamily="34" charset="-120"/>
+              </a:rPr>
+              <a:t>→  On emprunte le badge</a:t>
+            </a:r>
+            <a:endParaRPr lang="en-US" sz="1250" dirty="0"/>
+          </a:p>
+        </p:txBody>
+      </p:sp>
+      <p:sp>
+        <p:nvSpPr>
+          <p:cNvPr id="21" name="Shape 19"/>
           <p:cNvSpPr/>
           <p:nvPr/>
         </p:nvSpPr>
         <p:spPr>
           <a:xfrm>
-            <a:off x="7452360" y="3886200"/>
+            <a:off x="8641080" y="3886200"/>
             <a:ext cx="0" cy="530352"/>
           </a:xfrm>
           <a:prstGeom prst="line">
@@ -1660,14 +1749,14 @@
       </p:sp>
       <p:sp>
         <p:nvSpPr>
-          <p:cNvPr id="19" name="Text 17"/>
-          <p:cNvSpPr txBox="1"/>
-          <p:nvPr/>
-        </p:nvSpPr>
-        <p:spPr>
-          <a:xfrm>
-            <a:off x="7635240" y="3739896"/>
-            <a:ext cx="3977640" cy="822960"/>
+          <p:cNvPr id="22" name="Text 20"/>
+          <p:cNvSpPr txBox="1"/>
+          <p:nvPr/>
+        </p:nvSpPr>
+        <p:spPr>
+          <a:xfrm>
+            <a:off x="8823960" y="3739896"/>
+            <a:ext cx="2788920" cy="822960"/>
           </a:xfrm>
           <a:prstGeom prst="rect">
             <a:avLst/>
@@ -1683,7 +1772,7 @@
               <a:buNone/>
             </a:pPr>
             <a:r>
-              <a:rPr lang="en-US" sz="1350" b="1" dirty="0">
+              <a:rPr lang="en-US" sz="1200" dirty="0">
                 <a:solidFill>
                   <a:srgbClr val="6FBF95"/>
                 </a:solidFill>
@@ -1691,29 +1780,15 @@
                 <a:ea typeface="Calibri" pitchFamily="34" charset="-122"/>
                 <a:cs typeface="Calibri" pitchFamily="34" charset="-120"/>
               </a:rPr>
-              <a:t>→  </a:t>
-            </a:r>
-            <a:pPr indent="0" marL="0">
-              <a:buNone/>
-            </a:pPr>
-            <a:r>
-              <a:rPr lang="en-US" sz="1350" dirty="0">
-                <a:solidFill>
-                  <a:srgbClr val="6FBF95"/>
-                </a:solidFill>
-                <a:latin typeface="Calibri" pitchFamily="34" charset="0"/>
-                <a:ea typeface="Calibri" pitchFamily="34" charset="-122"/>
-                <a:cs typeface="Calibri" pitchFamily="34" charset="-120"/>
-              </a:rPr>
-              <a:t>Badge personnel porté sur soi</a:t>
-            </a:r>
-            <a:endParaRPr lang="en-US" sz="1350" dirty="0"/>
-          </a:p>
-        </p:txBody>
-      </p:sp>
-      <p:sp>
-        <p:nvSpPr>
-          <p:cNvPr id="20" name="Shape 18"/>
+              <a:t>Badge personnel, gardé sur soi</a:t>
+            </a:r>
+            <a:endParaRPr lang="en-US" sz="1200" dirty="0"/>
+          </a:p>
+        </p:txBody>
+      </p:sp>
+      <p:sp>
+        <p:nvSpPr>
+          <p:cNvPr id="23" name="Shape 21"/>
           <p:cNvSpPr/>
           <p:nvPr/>
         </p:nvSpPr>
@@ -1740,7 +1815,7 @@
       </p:sp>
       <p:sp>
         <p:nvSpPr>
-          <p:cNvPr id="21" name="Text 19"/>
+          <p:cNvPr id="24" name="Text 22"/>
           <p:cNvSpPr txBox="1"/>
           <p:nvPr/>
         </p:nvSpPr>
@@ -1779,14 +1854,14 @@
       </p:sp>
       <p:sp>
         <p:nvSpPr>
-          <p:cNvPr id="22" name="Text 20"/>
+          <p:cNvPr id="25" name="Text 23"/>
           <p:cNvSpPr txBox="1"/>
           <p:nvPr/>
         </p:nvSpPr>
         <p:spPr>
           <a:xfrm>
             <a:off x="1280160" y="4672584"/>
-            <a:ext cx="6035040" cy="822960"/>
+            <a:ext cx="4480560" cy="822960"/>
           </a:xfrm>
           <a:prstGeom prst="rect">
             <a:avLst/>
@@ -1802,7 +1877,7 @@
               <a:buNone/>
             </a:pPr>
             <a:r>
-              <a:rPr lang="en-US" sz="1500" dirty="0">
+              <a:rPr lang="en-US" sz="1450" dirty="0">
                 <a:solidFill>
                   <a:srgbClr val="ECF1F5"/>
                 </a:solidFill>
@@ -1810,21 +1885,60 @@
                 <a:ea typeface="Calibri" pitchFamily="34" charset="-122"/>
                 <a:cs typeface="Calibri" pitchFamily="34" charset="-120"/>
               </a:rPr>
-              <a:t>Automate (PLC) laissé ouvert</a:t>
-            </a:r>
-            <a:endParaRPr lang="en-US" sz="1500" dirty="0"/>
-          </a:p>
-        </p:txBody>
-      </p:sp>
-      <p:sp>
-        <p:nvSpPr>
-          <p:cNvPr id="23" name="Shape 21"/>
+              <a:t>L'armoire de l'automate laissée ouverte</a:t>
+            </a:r>
+            <a:endParaRPr lang="en-US" sz="1450" dirty="0"/>
+          </a:p>
+        </p:txBody>
+      </p:sp>
+      <p:sp>
+        <p:nvSpPr>
+          <p:cNvPr id="26" name="Text 24"/>
+          <p:cNvSpPr txBox="1"/>
+          <p:nvPr/>
+        </p:nvSpPr>
+        <p:spPr>
+          <a:xfrm>
+            <a:off x="5852160" y="4672584"/>
+            <a:ext cx="2651760" cy="822960"/>
+          </a:xfrm>
+          <a:prstGeom prst="rect">
+            <a:avLst/>
+          </a:prstGeom>
+          <a:noFill/>
+          <a:ln/>
+        </p:spPr>
+        <p:txBody>
+          <a:bodyPr wrap="square" lIns="0" tIns="0" rIns="0" bIns="0" rtlCol="0" anchor="ctr"/>
+          <a:lstStyle/>
+          <a:p>
+            <a:pPr indent="0" marL="0">
+              <a:buNone/>
+            </a:pPr>
+            <a:r>
+              <a:rPr lang="en-US" sz="1250" dirty="0">
+                <a:solidFill>
+                  <a:srgbClr val="9DABB6"/>
+                </a:solidFill>
+                <a:latin typeface="Calibri" pitchFamily="34" charset="0"/>
+                <a:ea typeface="Calibri" pitchFamily="34" charset="-122"/>
+                <a:cs typeface="Calibri" pitchFamily="34" charset="-120"/>
+              </a:rPr>
+              <a:t>→  On agit directement sur les machines</a:t>
+            </a:r>
+            <a:endParaRPr lang="en-US" sz="1250" dirty="0"/>
+          </a:p>
+        </p:txBody>
+      </p:sp>
+      <p:sp>
+        <p:nvSpPr>
+          <p:cNvPr id="27" name="Shape 25"/>
           <p:cNvSpPr/>
           <p:nvPr/>
         </p:nvSpPr>
         <p:spPr>
           <a:xfrm>
-            <a:off x="7452360" y="4818888"/>
+            <a:off x="8641080" y="4818888"/>
             <a:ext cx="0" cy="530352"/>
           </a:xfrm>
           <a:prstGeom prst="line">
@@ -1841,14 +1955,14 @@
       </p:sp>
       <p:sp>
         <p:nvSpPr>
-          <p:cNvPr id="24" name="Text 22"/>
-          <p:cNvSpPr txBox="1"/>
-          <p:nvPr/>
-        </p:nvSpPr>
-        <p:spPr>
-          <a:xfrm>
-            <a:off x="7635240" y="4672584"/>
-            <a:ext cx="3977640" cy="822960"/>
+          <p:cNvPr id="28" name="Text 26"/>
+          <p:cNvSpPr txBox="1"/>
+          <p:nvPr/>
+        </p:nvSpPr>
+        <p:spPr>
+          <a:xfrm>
+            <a:off x="8823960" y="4672584"/>
+            <a:ext cx="2788920" cy="822960"/>
           </a:xfrm>
           <a:prstGeom prst="rect">
             <a:avLst/>
@@ -1864,7 +1978,7 @@
               <a:buNone/>
             </a:pPr>
             <a:r>
-              <a:rPr lang="en-US" sz="1350" b="1" dirty="0">
+              <a:rPr lang="en-US" sz="1200" dirty="0">
                 <a:solidFill>
                   <a:srgbClr val="6FBF95"/>
                 </a:solidFill>
@@ -1872,29 +1986,15 @@
                 <a:ea typeface="Calibri" pitchFamily="34" charset="-122"/>
                 <a:cs typeface="Calibri" pitchFamily="34" charset="-120"/>
               </a:rPr>
-              <a:t>→  </a:t>
-            </a:r>
-            <a:pPr indent="0" marL="0">
-              <a:buNone/>
-            </a:pPr>
-            <a:r>
-              <a:rPr lang="en-US" sz="1350" dirty="0">
-                <a:solidFill>
-                  <a:srgbClr val="6FBF95"/>
-                </a:solidFill>
-                <a:latin typeface="Calibri" pitchFamily="34" charset="0"/>
-                <a:ea typeface="Calibri" pitchFamily="34" charset="-122"/>
-                <a:cs typeface="Calibri" pitchFamily="34" charset="-120"/>
-              </a:rPr>
-              <a:t>Armoire à clé, commutateur RUN/PROG</a:t>
-            </a:r>
-            <a:endParaRPr lang="en-US" sz="1350" dirty="0"/>
-          </a:p>
-        </p:txBody>
-      </p:sp>
-      <p:sp>
-        <p:nvSpPr>
-          <p:cNvPr id="25" name="Shape 23"/>
+              <a:t>Armoire à clé, bouton physique de blocage</a:t>
+            </a:r>
+            <a:endParaRPr lang="en-US" sz="1200" dirty="0"/>
+          </a:p>
+        </p:txBody>
+      </p:sp>
+      <p:sp>
+        <p:nvSpPr>
+          <p:cNvPr id="29" name="Shape 27"/>
           <p:cNvSpPr/>
           <p:nvPr/>
         </p:nvSpPr>
@@ -1921,7 +2021,7 @@
       </p:sp>
       <p:sp>
         <p:nvSpPr>
-          <p:cNvPr id="26" name="Text 24"/>
+          <p:cNvPr id="30" name="Text 28"/>
           <p:cNvSpPr txBox="1"/>
           <p:nvPr/>
         </p:nvSpPr>
@@ -1960,14 +2060,14 @@
       </p:sp>
       <p:sp>
         <p:nvSpPr>
-          <p:cNvPr id="27" name="Text 25"/>
+          <p:cNvPr id="31" name="Text 29"/>
           <p:cNvSpPr txBox="1"/>
           <p:nvPr/>
         </p:nvSpPr>
         <p:spPr>
           <a:xfrm>
             <a:off x="1280160" y="5605272"/>
-            <a:ext cx="6035040" cy="822960"/>
+            <a:ext cx="4480560" cy="822960"/>
           </a:xfrm>
           <a:prstGeom prst="rect">
             <a:avLst/>
@@ -1983,7 +2083,7 @@
               <a:buNone/>
             </a:pPr>
             <a:r>
-              <a:rPr lang="en-US" sz="1500" dirty="0">
+              <a:rPr lang="en-US" sz="1450" dirty="0">
                 <a:solidFill>
                   <a:srgbClr val="ECF1F5"/>
                 </a:solidFill>
@@ -1991,21 +2091,60 @@
                 <a:ea typeface="Calibri" pitchFamily="34" charset="-122"/>
                 <a:cs typeface="Calibri" pitchFamily="34" charset="-120"/>
               </a:rPr>
-              <a:t>IHM utilisable sans se connecter</a:t>
-            </a:r>
-            <a:endParaRPr lang="en-US" sz="1500" dirty="0"/>
-          </a:p>
-        </p:txBody>
-      </p:sp>
-      <p:sp>
-        <p:nvSpPr>
-          <p:cNvPr id="28" name="Shape 26"/>
+              <a:t>L'écran de supervision utilisable sans se connecter</a:t>
+            </a:r>
+            <a:endParaRPr lang="en-US" sz="1450" dirty="0"/>
+          </a:p>
+        </p:txBody>
+      </p:sp>
+      <p:sp>
+        <p:nvSpPr>
+          <p:cNvPr id="32" name="Text 30"/>
+          <p:cNvSpPr txBox="1"/>
+          <p:nvPr/>
+        </p:nvSpPr>
+        <p:spPr>
+          <a:xfrm>
+            <a:off x="5852160" y="5605272"/>
+            <a:ext cx="2651760" cy="822960"/>
+          </a:xfrm>
+          <a:prstGeom prst="rect">
+            <a:avLst/>
+          </a:prstGeom>
+          <a:noFill/>
+          <a:ln/>
+        </p:spPr>
+        <p:txBody>
+          <a:bodyPr wrap="square" lIns="0" tIns="0" rIns="0" bIns="0" rtlCol="0" anchor="ctr"/>
+          <a:lstStyle/>
+          <a:p>
+            <a:pPr indent="0" marL="0">
+              <a:buNone/>
+            </a:pPr>
+            <a:r>
+              <a:rPr lang="en-US" sz="1250" dirty="0">
+                <a:solidFill>
+                  <a:srgbClr val="9DABB6"/>
+                </a:solidFill>
+                <a:latin typeface="Calibri" pitchFamily="34" charset="0"/>
+                <a:ea typeface="Calibri" pitchFamily="34" charset="-122"/>
+                <a:cs typeface="Calibri" pitchFamily="34" charset="-120"/>
+              </a:rPr>
+              <a:t>→  On pilote l'usine sans mot de passe</a:t>
+            </a:r>
+            <a:endParaRPr lang="en-US" sz="1250" dirty="0"/>
+          </a:p>
+        </p:txBody>
+      </p:sp>
+      <p:sp>
+        <p:nvSpPr>
+          <p:cNvPr id="33" name="Shape 31"/>
           <p:cNvSpPr/>
           <p:nvPr/>
         </p:nvSpPr>
         <p:spPr>
           <a:xfrm>
-            <a:off x="7452360" y="5751576"/>
+            <a:off x="8641080" y="5751576"/>
             <a:ext cx="0" cy="530352"/>
           </a:xfrm>
           <a:prstGeom prst="line">
@@ -2022,14 +2161,14 @@
       </p:sp>
       <p:sp>
         <p:nvSpPr>
-          <p:cNvPr id="29" name="Text 27"/>
-          <p:cNvSpPr txBox="1"/>
-          <p:nvPr/>
-        </p:nvSpPr>
-        <p:spPr>
-          <a:xfrm>
-            <a:off x="7635240" y="5605272"/>
-            <a:ext cx="3977640" cy="822960"/>
+          <p:cNvPr id="34" name="Text 32"/>
+          <p:cNvSpPr txBox="1"/>
+          <p:nvPr/>
+        </p:nvSpPr>
+        <p:spPr>
+          <a:xfrm>
+            <a:off x="8823960" y="5605272"/>
+            <a:ext cx="2788920" cy="822960"/>
           </a:xfrm>
           <a:prstGeom prst="rect">
             <a:avLst/>
@@ -2045,7 +2184,7 @@
               <a:buNone/>
             </a:pPr>
             <a:r>
-              <a:rPr lang="en-US" sz="1350" b="1" dirty="0">
+              <a:rPr lang="en-US" sz="1200" dirty="0">
                 <a:solidFill>
                   <a:srgbClr val="6FBF95"/>
                 </a:solidFill>
@@ -2053,29 +2192,15 @@
                 <a:ea typeface="Calibri" pitchFamily="34" charset="-122"/>
                 <a:cs typeface="Calibri" pitchFamily="34" charset="-120"/>
               </a:rPr>
-              <a:t>→  </a:t>
-            </a:r>
-            <a:pPr indent="0" marL="0">
-              <a:buNone/>
-            </a:pPr>
-            <a:r>
-              <a:rPr lang="en-US" sz="1350" dirty="0">
-                <a:solidFill>
-                  <a:srgbClr val="6FBF95"/>
-                </a:solidFill>
-                <a:latin typeface="Calibri" pitchFamily="34" charset="0"/>
-                <a:ea typeface="Calibri" pitchFamily="34" charset="-122"/>
-                <a:cs typeface="Calibri" pitchFamily="34" charset="-120"/>
-              </a:rPr>
-              <a:t>Verrouillage de session, authentification</a:t>
-            </a:r>
-            <a:endParaRPr lang="en-US" sz="1350" dirty="0"/>
-          </a:p>
-        </p:txBody>
-      </p:sp>
-      <p:sp>
-        <p:nvSpPr>
-          <p:cNvPr id="30" name="Text 28"/>
+              <a:t>Session qui se verrouille, connexion obligatoire</a:t>
+            </a:r>
+            <a:endParaRPr lang="en-US" sz="1200" dirty="0"/>
+          </a:p>
+        </p:txBody>
+      </p:sp>
+      <p:sp>
+        <p:nvSpPr>
+          <p:cNvPr id="35" name="Text 33"/>
           <p:cNvSpPr txBox="1"/>
           <p:nvPr/>
         </p:nvSpPr>
@@ -2106,7 +2231,7 @@
                 <a:ea typeface="Calibri" pitchFamily="34" charset="-122"/>
                 <a:cs typeface="Calibri" pitchFamily="34" charset="-120"/>
               </a:rPr>
-              <a:t>La plupart relèvent du comportement → le correctif transverse est la formation &amp; la sensibilisation (chiffrée en partie 3).</a:t>
+              <a:t>Presque tout relève de l'habitude, pas de la technique → la meilleure parade est la formation des équipes.</a:t>
             </a:r>
             <a:endParaRPr lang="en-US" sz="1200" dirty="0"/>
           </a:p>
@@ -2114,7 +2239,7 @@
       </p:sp>
       <p:sp>
         <p:nvSpPr>
-          <p:cNvPr id="31" name="Text 29"/>
+          <p:cNvPr id="36" name="Text 34"/>
           <p:cNvSpPr txBox="1"/>
           <p:nvPr/>
         </p:nvSpPr>
@@ -2159,7 +2284,7 @@
                 <a:ea typeface="Calibri" pitchFamily="34" charset="-122"/>
                 <a:cs typeface="Calibri" pitchFamily="34" charset="-120"/>
               </a:rPr>
-              <a:t>        L'attaque a commencé ici : mots de passe ramassés à la main</a:t>
+              <a:t>        L'attaque a commencé ici : les mots de passe ont été ramassés à la main</a:t>
             </a:r>
             <a:endParaRPr lang="en-US" sz="950" dirty="0"/>
           </a:p>
@@ -2167,7 +2292,7 @@
       </p:sp>
       <p:sp>
         <p:nvSpPr>
-          <p:cNvPr id="32" name="Shape 30"/>
+          <p:cNvPr id="37" name="Shape 35"/>
           <p:cNvSpPr/>
           <p:nvPr/>
         </p:nvSpPr>
@@ -2287,7 +2412,7 @@
                 <a:ea typeface="Calibri" pitchFamily="34" charset="-122"/>
                 <a:cs typeface="Calibri" pitchFamily="34" charset="-120"/>
               </a:rPr>
-              <a:t>   ANALYSE DES VULNÉRABILITÉS — LOGIQUES &amp; LOGICIELLES</a:t>
+              <a:t>   LES FAILLES INFORMATIQUES — EXPLIQUÉES SIMPLEMENT</a:t>
             </a:r>
             <a:endParaRPr lang="en-US" sz="1100" dirty="0"/>
           </a:p>
@@ -2329,7 +2454,7 @@
                 <a:ea typeface="Cambria" pitchFamily="34" charset="-122"/>
                 <a:cs typeface="Cambria" pitchFamily="34" charset="-120"/>
               </a:rPr>
-              <a:t>4 failles mènent de la DMZ à l'explosion</a:t>
+              <a:t>4 failles mènent du bureau jusqu'à l'explosion</a:t>
             </a:r>
             <a:endParaRPr lang="en-US" sz="3200" dirty="0"/>
           </a:p>
@@ -2343,12 +2468,12 @@
         </p:nvSpPr>
         <p:spPr>
           <a:xfrm>
-            <a:off x="502920" y="1874520"/>
-            <a:ext cx="5468112" cy="2084832"/>
+            <a:off x="502920" y="1828800"/>
+            <a:ext cx="5468112" cy="2011680"/>
           </a:xfrm>
           <a:prstGeom prst="roundRect">
             <a:avLst>
-              <a:gd name="adj" fmla="val 2632"/>
+              <a:gd name="adj" fmla="val 2727"/>
             </a:avLst>
           </a:prstGeom>
           <a:solidFill>
@@ -2370,8 +2495,8 @@
         </p:nvSpPr>
         <p:spPr>
           <a:xfrm>
-            <a:off x="502920" y="1874520"/>
-            <a:ext cx="73152" cy="2084832"/>
+            <a:off x="502920" y="1828800"/>
+            <a:ext cx="73152" cy="2011680"/>
           </a:xfrm>
           <a:prstGeom prst="rect">
             <a:avLst/>
@@ -2390,8 +2515,128 @@
         </p:nvSpPr>
         <p:spPr>
           <a:xfrm>
-            <a:off x="731520" y="2020824"/>
-            <a:ext cx="5010912" cy="365760"/>
+            <a:off x="740664" y="1975104"/>
+            <a:ext cx="4992624" cy="475488"/>
+          </a:xfrm>
+          <a:prstGeom prst="rect">
+            <a:avLst/>
+          </a:prstGeom>
+          <a:noFill/>
+          <a:ln/>
+        </p:spPr>
+        <p:txBody>
+          <a:bodyPr wrap="square" lIns="0" tIns="0" rIns="0" bIns="0" rtlCol="0" anchor="t"/>
+          <a:lstStyle/>
+          <a:p>
+            <a:pPr indent="0" marL="0">
+              <a:lnSpc>
+                <a:spcPct val="95000"/>
+              </a:lnSpc>
+              <a:buNone/>
+            </a:pPr>
+            <a:r>
+              <a:rPr lang="en-US" sz="1550" b="1" dirty="0">
+                <a:solidFill>
+                  <a:srgbClr val="ECF1F5"/>
+                </a:solidFill>
+                <a:latin typeface="Calibri" pitchFamily="34" charset="0"/>
+                <a:ea typeface="Calibri" pitchFamily="34" charset="-122"/>
+                <a:cs typeface="Calibri" pitchFamily="34" charset="-120"/>
+              </a:rPr>
+              <a:t>Le filtre entre les bureaux et l'usine laisse tout passer</a:t>
+            </a:r>
+            <a:endParaRPr lang="en-US" sz="1550" dirty="0"/>
+          </a:p>
+        </p:txBody>
+      </p:sp>
+      <p:sp>
+        <p:nvSpPr>
+          <p:cNvPr id="8" name="Text 6"/>
+          <p:cNvSpPr txBox="1"/>
+          <p:nvPr/>
+        </p:nvSpPr>
+        <p:spPr>
+          <a:xfrm>
+            <a:off x="740664" y="2450592"/>
+            <a:ext cx="4992624" cy="182880"/>
+          </a:xfrm>
+          <a:prstGeom prst="rect">
+            <a:avLst/>
+          </a:prstGeom>
+          <a:noFill/>
+          <a:ln/>
+        </p:spPr>
+        <p:txBody>
+          <a:bodyPr wrap="square" lIns="0" tIns="0" rIns="0" bIns="0" rtlCol="0" anchor="t"/>
+          <a:lstStyle/>
+          <a:p>
+            <a:pPr indent="0" marL="0">
+              <a:buNone/>
+            </a:pPr>
+            <a:r>
+              <a:rPr lang="en-US" sz="1000" dirty="0">
+                <a:solidFill>
+                  <a:srgbClr val="E4796F"/>
+                </a:solidFill>
+                <a:latin typeface="Calibri" pitchFamily="34" charset="0"/>
+                <a:ea typeface="Calibri" pitchFamily="34" charset="-122"/>
+                <a:cs typeface="Calibri" pitchFamily="34" charset="-120"/>
+              </a:rPr>
+              <a:t>V1 — pare-feu ouvert</a:t>
+            </a:r>
+            <a:endParaRPr lang="en-US" sz="1000" dirty="0"/>
+          </a:p>
+        </p:txBody>
+      </p:sp>
+      <p:sp>
+        <p:nvSpPr>
+          <p:cNvPr id="9" name="Text 7"/>
+          <p:cNvSpPr txBox="1"/>
+          <p:nvPr/>
+        </p:nvSpPr>
+        <p:spPr>
+          <a:xfrm>
+            <a:off x="740664" y="2706624"/>
+            <a:ext cx="4992624" cy="713232"/>
+          </a:xfrm>
+          <a:prstGeom prst="rect">
+            <a:avLst/>
+          </a:prstGeom>
+          <a:noFill/>
+          <a:ln/>
+        </p:spPr>
+        <p:txBody>
+          <a:bodyPr wrap="square" lIns="0" tIns="0" rIns="0" bIns="0" rtlCol="0" anchor="t"/>
+          <a:lstStyle/>
+          <a:p>
+            <a:pPr indent="0" marL="0">
+              <a:buNone/>
+            </a:pPr>
+            <a:r>
+              <a:rPr lang="en-US" sz="1350" dirty="0">
+                <a:solidFill>
+                  <a:srgbClr val="9DABB6"/>
+                </a:solidFill>
+                <a:latin typeface="Calibri" pitchFamily="34" charset="0"/>
+                <a:ea typeface="Calibri" pitchFamily="34" charset="-122"/>
+                <a:cs typeface="Calibri" pitchFamily="34" charset="-120"/>
+              </a:rPr>
+              <a:t>Il a été réglé sur « autorise tout le monde » pour un test, et jamais remis en place.</a:t>
+            </a:r>
+            <a:endParaRPr lang="en-US" sz="1350" dirty="0"/>
+          </a:p>
+        </p:txBody>
+      </p:sp>
+      <p:sp>
+        <p:nvSpPr>
+          <p:cNvPr id="10" name="Text 8"/>
+          <p:cNvSpPr txBox="1"/>
+          <p:nvPr/>
+        </p:nvSpPr>
+        <p:spPr>
+          <a:xfrm>
+            <a:off x="740664" y="3474720"/>
+            <a:ext cx="4992624" cy="274320"/>
           </a:xfrm>
           <a:prstGeom prst="rect">
             <a:avLst/>
@@ -2407,165 +2652,6 @@
               <a:buNone/>
             </a:pPr>
             <a:r>
-              <a:rPr lang="en-US" sz="1700" b="1" dirty="0">
-                <a:solidFill>
-                  <a:srgbClr val="E4796F"/>
-                </a:solidFill>
-                <a:latin typeface="Calibri" pitchFamily="34" charset="0"/>
-                <a:ea typeface="Calibri" pitchFamily="34" charset="-122"/>
-                <a:cs typeface="Calibri" pitchFamily="34" charset="-120"/>
-              </a:rPr>
-              <a:t>V1  </a:t>
-            </a:r>
-            <a:pPr indent="0" marL="0">
-              <a:buNone/>
-            </a:pPr>
-            <a:r>
-              <a:rPr lang="en-US" sz="1700" b="1" dirty="0">
-                <a:solidFill>
-                  <a:srgbClr val="ECF1F5"/>
-                </a:solidFill>
-                <a:latin typeface="Calibri" pitchFamily="34" charset="0"/>
-                <a:ea typeface="Calibri" pitchFamily="34" charset="-122"/>
-                <a:cs typeface="Calibri" pitchFamily="34" charset="-120"/>
-              </a:rPr>
-              <a:t>Pare-feu ouvert</a:t>
-            </a:r>
-            <a:endParaRPr lang="en-US" sz="1700" dirty="0"/>
-          </a:p>
-        </p:txBody>
-      </p:sp>
-      <p:sp>
-        <p:nvSpPr>
-          <p:cNvPr id="8" name="Text 6"/>
-          <p:cNvSpPr txBox="1"/>
-          <p:nvPr/>
-        </p:nvSpPr>
-        <p:spPr>
-          <a:xfrm>
-            <a:off x="731520" y="2441448"/>
-            <a:ext cx="5010912" cy="603504"/>
-          </a:xfrm>
-          <a:prstGeom prst="rect">
-            <a:avLst/>
-          </a:prstGeom>
-          <a:noFill/>
-          <a:ln/>
-        </p:spPr>
-        <p:txBody>
-          <a:bodyPr wrap="square" lIns="0" tIns="0" rIns="0" bIns="0" rtlCol="0" anchor="t"/>
-          <a:lstStyle/>
-          <a:p>
-            <a:pPr indent="0" marL="0">
-              <a:buNone/>
-            </a:pPr>
-            <a:r>
-              <a:rPr lang="en-US" sz="1300" b="1" dirty="0">
-                <a:solidFill>
-                  <a:srgbClr val="6E7C87"/>
-                </a:solidFill>
-                <a:latin typeface="Calibri" pitchFamily="34" charset="0"/>
-                <a:ea typeface="Calibri" pitchFamily="34" charset="-122"/>
-                <a:cs typeface="Calibri" pitchFamily="34" charset="-120"/>
-              </a:rPr>
-              <a:t>C'est   </a:t>
-            </a:r>
-            <a:pPr indent="0" marL="0">
-              <a:buNone/>
-            </a:pPr>
-            <a:r>
-              <a:rPr lang="en-US" sz="1300" dirty="0">
-                <a:solidFill>
-                  <a:srgbClr val="9DABB6"/>
-                </a:solidFill>
-                <a:latin typeface="Calibri" pitchFamily="34" charset="0"/>
-                <a:ea typeface="Calibri" pitchFamily="34" charset="-122"/>
-                <a:cs typeface="Calibri" pitchFamily="34" charset="-120"/>
-              </a:rPr>
-              <a:t>Règle « ACCEPT all » : la DMZ atteint directement la zone procédé.</a:t>
-            </a:r>
-            <a:endParaRPr lang="en-US" sz="1300" dirty="0"/>
-          </a:p>
-        </p:txBody>
-      </p:sp>
-      <p:sp>
-        <p:nvSpPr>
-          <p:cNvPr id="9" name="Text 7"/>
-          <p:cNvSpPr txBox="1"/>
-          <p:nvPr/>
-        </p:nvSpPr>
-        <p:spPr>
-          <a:xfrm>
-            <a:off x="731520" y="3044952"/>
-            <a:ext cx="5010912" cy="402336"/>
-          </a:xfrm>
-          <a:prstGeom prst="rect">
-            <a:avLst/>
-          </a:prstGeom>
-          <a:noFill/>
-          <a:ln/>
-        </p:spPr>
-        <p:txBody>
-          <a:bodyPr wrap="square" lIns="0" tIns="0" rIns="0" bIns="0" rtlCol="0" anchor="t"/>
-          <a:lstStyle/>
-          <a:p>
-            <a:pPr indent="0" marL="0">
-              <a:buNone/>
-            </a:pPr>
-            <a:r>
-              <a:rPr lang="en-US" sz="1300" b="1" dirty="0">
-                <a:solidFill>
-                  <a:srgbClr val="6E7C87"/>
-                </a:solidFill>
-                <a:latin typeface="Calibri" pitchFamily="34" charset="0"/>
-                <a:ea typeface="Calibri" pitchFamily="34" charset="-122"/>
-                <a:cs typeface="Calibri" pitchFamily="34" charset="-120"/>
-              </a:rPr>
-              <a:t>Effet   </a:t>
-            </a:r>
-            <a:pPr indent="0" marL="0">
-              <a:buNone/>
-            </a:pPr>
-            <a:r>
-              <a:rPr lang="en-US" sz="1300" dirty="0">
-                <a:solidFill>
-                  <a:srgbClr val="9DABB6"/>
-                </a:solidFill>
-                <a:latin typeface="Calibri" pitchFamily="34" charset="0"/>
-                <a:ea typeface="Calibri" pitchFamily="34" charset="-122"/>
-                <a:cs typeface="Calibri" pitchFamily="34" charset="-120"/>
-              </a:rPr>
-              <a:t>Aucune séparation réelle.</a:t>
-            </a:r>
-            <a:endParaRPr lang="en-US" sz="1300" dirty="0"/>
-          </a:p>
-        </p:txBody>
-      </p:sp>
-      <p:sp>
-        <p:nvSpPr>
-          <p:cNvPr id="10" name="Text 8"/>
-          <p:cNvSpPr txBox="1"/>
-          <p:nvPr/>
-        </p:nvSpPr>
-        <p:spPr>
-          <a:xfrm>
-            <a:off x="731520" y="3502152"/>
-            <a:ext cx="5010912" cy="384048"/>
-          </a:xfrm>
-          <a:prstGeom prst="rect">
-            <a:avLst/>
-          </a:prstGeom>
-          <a:noFill/>
-          <a:ln/>
-        </p:spPr>
-        <p:txBody>
-          <a:bodyPr wrap="square" lIns="0" tIns="0" rIns="0" bIns="0" rtlCol="0" anchor="t"/>
-          <a:lstStyle/>
-          <a:p>
-            <a:pPr indent="0" marL="0">
-              <a:buNone/>
-            </a:pPr>
-            <a:r>
               <a:rPr lang="en-US" sz="1250" b="1" dirty="0">
                 <a:solidFill>
                   <a:srgbClr val="6FBF95"/>
@@ -2588,7 +2674,7 @@
                 <a:ea typeface="Calibri" pitchFamily="34" charset="-122"/>
                 <a:cs typeface="Calibri" pitchFamily="34" charset="-120"/>
               </a:rPr>
-              <a:t>Refus par défaut, une règle par flux</a:t>
+              <a:t>On bloque tout par défaut, on n'ouvre que le strict nécessaire</a:t>
             </a:r>
             <a:endParaRPr lang="en-US" sz="1250" dirty="0"/>
           </a:p>
@@ -2602,12 +2688,12 @@
         </p:nvSpPr>
         <p:spPr>
           <a:xfrm>
-            <a:off x="6190488" y="1874520"/>
-            <a:ext cx="5468112" cy="2084832"/>
+            <a:off x="6190488" y="1828800"/>
+            <a:ext cx="5468112" cy="2011680"/>
           </a:xfrm>
           <a:prstGeom prst="roundRect">
             <a:avLst>
-              <a:gd name="adj" fmla="val 2632"/>
+              <a:gd name="adj" fmla="val 2727"/>
             </a:avLst>
           </a:prstGeom>
           <a:solidFill>
@@ -2629,8 +2715,8 @@
         </p:nvSpPr>
         <p:spPr>
           <a:xfrm>
-            <a:off x="6190488" y="1874520"/>
-            <a:ext cx="73152" cy="2084832"/>
+            <a:off x="6190488" y="1828800"/>
+            <a:ext cx="73152" cy="2011680"/>
           </a:xfrm>
           <a:prstGeom prst="rect">
             <a:avLst/>
@@ -2649,8 +2735,128 @@
         </p:nvSpPr>
         <p:spPr>
           <a:xfrm>
-            <a:off x="6419088" y="2020824"/>
-            <a:ext cx="5010912" cy="365760"/>
+            <a:off x="6428232" y="1975104"/>
+            <a:ext cx="4992624" cy="475488"/>
+          </a:xfrm>
+          <a:prstGeom prst="rect">
+            <a:avLst/>
+          </a:prstGeom>
+          <a:noFill/>
+          <a:ln/>
+        </p:spPr>
+        <p:txBody>
+          <a:bodyPr wrap="square" lIns="0" tIns="0" rIns="0" bIns="0" rtlCol="0" anchor="t"/>
+          <a:lstStyle/>
+          <a:p>
+            <a:pPr indent="0" marL="0">
+              <a:lnSpc>
+                <a:spcPct val="95000"/>
+              </a:lnSpc>
+              <a:buNone/>
+            </a:pPr>
+            <a:r>
+              <a:rPr lang="en-US" sz="1550" b="1" dirty="0">
+                <a:solidFill>
+                  <a:srgbClr val="ECF1F5"/>
+                </a:solidFill>
+                <a:latin typeface="Calibri" pitchFamily="34" charset="0"/>
+                <a:ea typeface="Calibri" pitchFamily="34" charset="-122"/>
+                <a:cs typeface="Calibri" pitchFamily="34" charset="-120"/>
+              </a:rPr>
+              <a:t>Les ordres envoyés aux machines ne sont pas vérifiés</a:t>
+            </a:r>
+            <a:endParaRPr lang="en-US" sz="1550" dirty="0"/>
+          </a:p>
+        </p:txBody>
+      </p:sp>
+      <p:sp>
+        <p:nvSpPr>
+          <p:cNvPr id="14" name="Text 12"/>
+          <p:cNvSpPr txBox="1"/>
+          <p:nvPr/>
+        </p:nvSpPr>
+        <p:spPr>
+          <a:xfrm>
+            <a:off x="6428232" y="2450592"/>
+            <a:ext cx="4992624" cy="182880"/>
+          </a:xfrm>
+          <a:prstGeom prst="rect">
+            <a:avLst/>
+          </a:prstGeom>
+          <a:noFill/>
+          <a:ln/>
+        </p:spPr>
+        <p:txBody>
+          <a:bodyPr wrap="square" lIns="0" tIns="0" rIns="0" bIns="0" rtlCol="0" anchor="t"/>
+          <a:lstStyle/>
+          <a:p>
+            <a:pPr indent="0" marL="0">
+              <a:buNone/>
+            </a:pPr>
+            <a:r>
+              <a:rPr lang="en-US" sz="1000" dirty="0">
+                <a:solidFill>
+                  <a:srgbClr val="E4796F"/>
+                </a:solidFill>
+                <a:latin typeface="Calibri" pitchFamily="34" charset="0"/>
+                <a:ea typeface="Calibri" pitchFamily="34" charset="-122"/>
+                <a:cs typeface="Calibri" pitchFamily="34" charset="-120"/>
+              </a:rPr>
+              <a:t>V3 — Modbus sans authentification</a:t>
+            </a:r>
+            <a:endParaRPr lang="en-US" sz="1000" dirty="0"/>
+          </a:p>
+        </p:txBody>
+      </p:sp>
+      <p:sp>
+        <p:nvSpPr>
+          <p:cNvPr id="15" name="Text 13"/>
+          <p:cNvSpPr txBox="1"/>
+          <p:nvPr/>
+        </p:nvSpPr>
+        <p:spPr>
+          <a:xfrm>
+            <a:off x="6428232" y="2706624"/>
+            <a:ext cx="4992624" cy="713232"/>
+          </a:xfrm>
+          <a:prstGeom prst="rect">
+            <a:avLst/>
+          </a:prstGeom>
+          <a:noFill/>
+          <a:ln/>
+        </p:spPr>
+        <p:txBody>
+          <a:bodyPr wrap="square" lIns="0" tIns="0" rIns="0" bIns="0" rtlCol="0" anchor="t"/>
+          <a:lstStyle/>
+          <a:p>
+            <a:pPr indent="0" marL="0">
+              <a:buNone/>
+            </a:pPr>
+            <a:r>
+              <a:rPr lang="en-US" sz="1350" dirty="0">
+                <a:solidFill>
+                  <a:srgbClr val="9DABB6"/>
+                </a:solidFill>
+                <a:latin typeface="Calibri" pitchFamily="34" charset="0"/>
+                <a:ea typeface="Calibri" pitchFamily="34" charset="-122"/>
+                <a:cs typeface="Calibri" pitchFamily="34" charset="-120"/>
+              </a:rPr>
+              <a:t>N'importe qui peut commander une vanne : rien ne vérifie qui envoie l'ordre, et tout circule en clair.</a:t>
+            </a:r>
+            <a:endParaRPr lang="en-US" sz="1350" dirty="0"/>
+          </a:p>
+        </p:txBody>
+      </p:sp>
+      <p:sp>
+        <p:nvSpPr>
+          <p:cNvPr id="16" name="Text 14"/>
+          <p:cNvSpPr txBox="1"/>
+          <p:nvPr/>
+        </p:nvSpPr>
+        <p:spPr>
+          <a:xfrm>
+            <a:off x="6428232" y="3474720"/>
+            <a:ext cx="4992624" cy="274320"/>
           </a:xfrm>
           <a:prstGeom prst="rect">
             <a:avLst/>
@@ -2666,165 +2872,6 @@
               <a:buNone/>
             </a:pPr>
             <a:r>
-              <a:rPr lang="en-US" sz="1700" b="1" dirty="0">
-                <a:solidFill>
-                  <a:srgbClr val="E4796F"/>
-                </a:solidFill>
-                <a:latin typeface="Calibri" pitchFamily="34" charset="0"/>
-                <a:ea typeface="Calibri" pitchFamily="34" charset="-122"/>
-                <a:cs typeface="Calibri" pitchFamily="34" charset="-120"/>
-              </a:rPr>
-              <a:t>V3  </a:t>
-            </a:r>
-            <a:pPr indent="0" marL="0">
-              <a:buNone/>
-            </a:pPr>
-            <a:r>
-              <a:rPr lang="en-US" sz="1700" b="1" dirty="0">
-                <a:solidFill>
-                  <a:srgbClr val="ECF1F5"/>
-                </a:solidFill>
-                <a:latin typeface="Calibri" pitchFamily="34" charset="0"/>
-                <a:ea typeface="Calibri" pitchFamily="34" charset="-122"/>
-                <a:cs typeface="Calibri" pitchFamily="34" charset="-120"/>
-              </a:rPr>
-              <a:t>Modbus sans authentification</a:t>
-            </a:r>
-            <a:endParaRPr lang="en-US" sz="1700" dirty="0"/>
-          </a:p>
-        </p:txBody>
-      </p:sp>
-      <p:sp>
-        <p:nvSpPr>
-          <p:cNvPr id="14" name="Text 12"/>
-          <p:cNvSpPr txBox="1"/>
-          <p:nvPr/>
-        </p:nvSpPr>
-        <p:spPr>
-          <a:xfrm>
-            <a:off x="6419088" y="2441448"/>
-            <a:ext cx="5010912" cy="603504"/>
-          </a:xfrm>
-          <a:prstGeom prst="rect">
-            <a:avLst/>
-          </a:prstGeom>
-          <a:noFill/>
-          <a:ln/>
-        </p:spPr>
-        <p:txBody>
-          <a:bodyPr wrap="square" lIns="0" tIns="0" rIns="0" bIns="0" rtlCol="0" anchor="t"/>
-          <a:lstStyle/>
-          <a:p>
-            <a:pPr indent="0" marL="0">
-              <a:buNone/>
-            </a:pPr>
-            <a:r>
-              <a:rPr lang="en-US" sz="1300" b="1" dirty="0">
-                <a:solidFill>
-                  <a:srgbClr val="6E7C87"/>
-                </a:solidFill>
-                <a:latin typeface="Calibri" pitchFamily="34" charset="0"/>
-                <a:ea typeface="Calibri" pitchFamily="34" charset="-122"/>
-                <a:cs typeface="Calibri" pitchFamily="34" charset="-120"/>
-              </a:rPr>
-              <a:t>C'est   </a:t>
-            </a:r>
-            <a:pPr indent="0" marL="0">
-              <a:buNone/>
-            </a:pPr>
-            <a:r>
-              <a:rPr lang="en-US" sz="1300" dirty="0">
-                <a:solidFill>
-                  <a:srgbClr val="9DABB6"/>
-                </a:solidFill>
-                <a:latin typeface="Calibri" pitchFamily="34" charset="0"/>
-                <a:ea typeface="Calibri" pitchFamily="34" charset="-122"/>
-                <a:cs typeface="Calibri" pitchFamily="34" charset="-120"/>
-              </a:rPr>
-              <a:t>Le port 502 circule en clair, sans identité ni signature.</a:t>
-            </a:r>
-            <a:endParaRPr lang="en-US" sz="1300" dirty="0"/>
-          </a:p>
-        </p:txBody>
-      </p:sp>
-      <p:sp>
-        <p:nvSpPr>
-          <p:cNvPr id="15" name="Text 13"/>
-          <p:cNvSpPr txBox="1"/>
-          <p:nvPr/>
-        </p:nvSpPr>
-        <p:spPr>
-          <a:xfrm>
-            <a:off x="6419088" y="3044952"/>
-            <a:ext cx="5010912" cy="402336"/>
-          </a:xfrm>
-          <a:prstGeom prst="rect">
-            <a:avLst/>
-          </a:prstGeom>
-          <a:noFill/>
-          <a:ln/>
-        </p:spPr>
-        <p:txBody>
-          <a:bodyPr wrap="square" lIns="0" tIns="0" rIns="0" bIns="0" rtlCol="0" anchor="t"/>
-          <a:lstStyle/>
-          <a:p>
-            <a:pPr indent="0" marL="0">
-              <a:buNone/>
-            </a:pPr>
-            <a:r>
-              <a:rPr lang="en-US" sz="1300" b="1" dirty="0">
-                <a:solidFill>
-                  <a:srgbClr val="6E7C87"/>
-                </a:solidFill>
-                <a:latin typeface="Calibri" pitchFamily="34" charset="0"/>
-                <a:ea typeface="Calibri" pitchFamily="34" charset="-122"/>
-                <a:cs typeface="Calibri" pitchFamily="34" charset="-120"/>
-              </a:rPr>
-              <a:t>Effet   </a:t>
-            </a:r>
-            <a:pPr indent="0" marL="0">
-              <a:buNone/>
-            </a:pPr>
-            <a:r>
-              <a:rPr lang="en-US" sz="1300" dirty="0">
-                <a:solidFill>
-                  <a:srgbClr val="9DABB6"/>
-                </a:solidFill>
-                <a:latin typeface="Calibri" pitchFamily="34" charset="0"/>
-                <a:ea typeface="Calibri" pitchFamily="34" charset="-122"/>
-                <a:cs typeface="Calibri" pitchFamily="34" charset="-120"/>
-              </a:rPr>
-              <a:t>Quiconque l'atteint lit et écrit les vannes.</a:t>
-            </a:r>
-            <a:endParaRPr lang="en-US" sz="1300" dirty="0"/>
-          </a:p>
-        </p:txBody>
-      </p:sp>
-      <p:sp>
-        <p:nvSpPr>
-          <p:cNvPr id="16" name="Text 14"/>
-          <p:cNvSpPr txBox="1"/>
-          <p:nvPr/>
-        </p:nvSpPr>
-        <p:spPr>
-          <a:xfrm>
-            <a:off x="6419088" y="3502152"/>
-            <a:ext cx="5010912" cy="384048"/>
-          </a:xfrm>
-          <a:prstGeom prst="rect">
-            <a:avLst/>
-          </a:prstGeom>
-          <a:noFill/>
-          <a:ln/>
-        </p:spPr>
-        <p:txBody>
-          <a:bodyPr wrap="square" lIns="0" tIns="0" rIns="0" bIns="0" rtlCol="0" anchor="t"/>
-          <a:lstStyle/>
-          <a:p>
-            <a:pPr indent="0" marL="0">
-              <a:buNone/>
-            </a:pPr>
-            <a:r>
               <a:rPr lang="en-US" sz="1250" b="1" dirty="0">
                 <a:solidFill>
                   <a:srgbClr val="6FBF95"/>
@@ -2847,7 +2894,7 @@
                 <a:ea typeface="Calibri" pitchFamily="34" charset="-122"/>
                 <a:cs typeface="Calibri" pitchFamily="34" charset="-120"/>
               </a:rPr>
-              <a:t>Pare-feu à inspection Modbus, à terme Modbus/TLS</a:t>
+              <a:t>Un filtre qui comprend ces ordres et n'autorise que les bons</a:t>
             </a:r>
             <a:endParaRPr lang="en-US" sz="1250" dirty="0"/>
           </a:p>
@@ -2861,12 +2908,12 @@
         </p:nvSpPr>
         <p:spPr>
           <a:xfrm>
-            <a:off x="502920" y="4160520"/>
-            <a:ext cx="5468112" cy="2084832"/>
+            <a:off x="502920" y="4059936"/>
+            <a:ext cx="5468112" cy="2011680"/>
           </a:xfrm>
           <a:prstGeom prst="roundRect">
             <a:avLst>
-              <a:gd name="adj" fmla="val 2632"/>
+              <a:gd name="adj" fmla="val 2727"/>
             </a:avLst>
           </a:prstGeom>
           <a:solidFill>
@@ -2888,8 +2935,8 @@
         </p:nvSpPr>
         <p:spPr>
           <a:xfrm>
-            <a:off x="502920" y="4160520"/>
-            <a:ext cx="73152" cy="2084832"/>
+            <a:off x="502920" y="4059936"/>
+            <a:ext cx="73152" cy="2011680"/>
           </a:xfrm>
           <a:prstGeom prst="rect">
             <a:avLst/>
@@ -2908,8 +2955,128 @@
         </p:nvSpPr>
         <p:spPr>
           <a:xfrm>
-            <a:off x="731520" y="4306824"/>
-            <a:ext cx="5010912" cy="365760"/>
+            <a:off x="740664" y="4206240"/>
+            <a:ext cx="4992624" cy="475488"/>
+          </a:xfrm>
+          <a:prstGeom prst="rect">
+            <a:avLst/>
+          </a:prstGeom>
+          <a:noFill/>
+          <a:ln/>
+        </p:spPr>
+        <p:txBody>
+          <a:bodyPr wrap="square" lIns="0" tIns="0" rIns="0" bIns="0" rtlCol="0" anchor="t"/>
+          <a:lstStyle/>
+          <a:p>
+            <a:pPr indent="0" marL="0">
+              <a:lnSpc>
+                <a:spcPct val="95000"/>
+              </a:lnSpc>
+              <a:buNone/>
+            </a:pPr>
+            <a:r>
+              <a:rPr lang="en-US" sz="1550" b="1" dirty="0">
+                <a:solidFill>
+                  <a:srgbClr val="ECF1F5"/>
+                </a:solidFill>
+                <a:latin typeface="Calibri" pitchFamily="34" charset="0"/>
+                <a:ea typeface="Calibri" pitchFamily="34" charset="-122"/>
+                <a:cs typeface="Calibri" pitchFamily="34" charset="-120"/>
+              </a:rPr>
+              <a:t>Personne ne surveille, rien n'est enregistré</a:t>
+            </a:r>
+            <a:endParaRPr lang="en-US" sz="1550" dirty="0"/>
+          </a:p>
+        </p:txBody>
+      </p:sp>
+      <p:sp>
+        <p:nvSpPr>
+          <p:cNvPr id="20" name="Text 18"/>
+          <p:cNvSpPr txBox="1"/>
+          <p:nvPr/>
+        </p:nvSpPr>
+        <p:spPr>
+          <a:xfrm>
+            <a:off x="740664" y="4681728"/>
+            <a:ext cx="4992624" cy="182880"/>
+          </a:xfrm>
+          <a:prstGeom prst="rect">
+            <a:avLst/>
+          </a:prstGeom>
+          <a:noFill/>
+          <a:ln/>
+        </p:spPr>
+        <p:txBody>
+          <a:bodyPr wrap="square" lIns="0" tIns="0" rIns="0" bIns="0" rtlCol="0" anchor="t"/>
+          <a:lstStyle/>
+          <a:p>
+            <a:pPr indent="0" marL="0">
+              <a:buNone/>
+            </a:pPr>
+            <a:r>
+              <a:rPr lang="en-US" sz="1000" dirty="0">
+                <a:solidFill>
+                  <a:srgbClr val="E0A64A"/>
+                </a:solidFill>
+                <a:latin typeface="Calibri" pitchFamily="34" charset="0"/>
+                <a:ea typeface="Calibri" pitchFamily="34" charset="-122"/>
+                <a:cs typeface="Calibri" pitchFamily="34" charset="-120"/>
+              </a:rPr>
+              <a:t>V7 · V8 — ni détection, ni journalisation</a:t>
+            </a:r>
+            <a:endParaRPr lang="en-US" sz="1000" dirty="0"/>
+          </a:p>
+        </p:txBody>
+      </p:sp>
+      <p:sp>
+        <p:nvSpPr>
+          <p:cNvPr id="21" name="Text 19"/>
+          <p:cNvSpPr txBox="1"/>
+          <p:nvPr/>
+        </p:nvSpPr>
+        <p:spPr>
+          <a:xfrm>
+            <a:off x="740664" y="4937760"/>
+            <a:ext cx="4992624" cy="713232"/>
+          </a:xfrm>
+          <a:prstGeom prst="rect">
+            <a:avLst/>
+          </a:prstGeom>
+          <a:noFill/>
+          <a:ln/>
+        </p:spPr>
+        <p:txBody>
+          <a:bodyPr wrap="square" lIns="0" tIns="0" rIns="0" bIns="0" rtlCol="0" anchor="t"/>
+          <a:lstStyle/>
+          <a:p>
+            <a:pPr indent="0" marL="0">
+              <a:buNone/>
+            </a:pPr>
+            <a:r>
+              <a:rPr lang="en-US" sz="1350" dirty="0">
+                <a:solidFill>
+                  <a:srgbClr val="9DABB6"/>
+                </a:solidFill>
+                <a:latin typeface="Calibri" pitchFamily="34" charset="0"/>
+                <a:ea typeface="Calibri" pitchFamily="34" charset="-122"/>
+                <a:cs typeface="Calibri" pitchFamily="34" charset="-120"/>
+              </a:rPr>
+              <a:t>Aucun outil ne regarde le réseau de l'usine, et aucun historique n'est conservé.</a:t>
+            </a:r>
+            <a:endParaRPr lang="en-US" sz="1350" dirty="0"/>
+          </a:p>
+        </p:txBody>
+      </p:sp>
+      <p:sp>
+        <p:nvSpPr>
+          <p:cNvPr id="22" name="Text 20"/>
+          <p:cNvSpPr txBox="1"/>
+          <p:nvPr/>
+        </p:nvSpPr>
+        <p:spPr>
+          <a:xfrm>
+            <a:off x="740664" y="5705856"/>
+            <a:ext cx="4992624" cy="274320"/>
           </a:xfrm>
           <a:prstGeom prst="rect">
             <a:avLst/>
@@ -2925,165 +3092,6 @@
               <a:buNone/>
             </a:pPr>
             <a:r>
-              <a:rPr lang="en-US" sz="1700" b="1" dirty="0">
-                <a:solidFill>
-                  <a:srgbClr val="E0A64A"/>
-                </a:solidFill>
-                <a:latin typeface="Calibri" pitchFamily="34" charset="0"/>
-                <a:ea typeface="Calibri" pitchFamily="34" charset="-122"/>
-                <a:cs typeface="Calibri" pitchFamily="34" charset="-120"/>
-              </a:rPr>
-              <a:t>V7·V8  </a:t>
-            </a:r>
-            <a:pPr indent="0" marL="0">
-              <a:buNone/>
-            </a:pPr>
-            <a:r>
-              <a:rPr lang="en-US" sz="1700" b="1" dirty="0">
-                <a:solidFill>
-                  <a:srgbClr val="ECF1F5"/>
-                </a:solidFill>
-                <a:latin typeface="Calibri" pitchFamily="34" charset="0"/>
-                <a:ea typeface="Calibri" pitchFamily="34" charset="-122"/>
-                <a:cs typeface="Calibri" pitchFamily="34" charset="-120"/>
-              </a:rPr>
-              <a:t>Ni détection, ni journalisation</a:t>
-            </a:r>
-            <a:endParaRPr lang="en-US" sz="1700" dirty="0"/>
-          </a:p>
-        </p:txBody>
-      </p:sp>
-      <p:sp>
-        <p:nvSpPr>
-          <p:cNvPr id="20" name="Text 18"/>
-          <p:cNvSpPr txBox="1"/>
-          <p:nvPr/>
-        </p:nvSpPr>
-        <p:spPr>
-          <a:xfrm>
-            <a:off x="731520" y="4727448"/>
-            <a:ext cx="5010912" cy="603504"/>
-          </a:xfrm>
-          <a:prstGeom prst="rect">
-            <a:avLst/>
-          </a:prstGeom>
-          <a:noFill/>
-          <a:ln/>
-        </p:spPr>
-        <p:txBody>
-          <a:bodyPr wrap="square" lIns="0" tIns="0" rIns="0" bIns="0" rtlCol="0" anchor="t"/>
-          <a:lstStyle/>
-          <a:p>
-            <a:pPr indent="0" marL="0">
-              <a:buNone/>
-            </a:pPr>
-            <a:r>
-              <a:rPr lang="en-US" sz="1300" b="1" dirty="0">
-                <a:solidFill>
-                  <a:srgbClr val="6E7C87"/>
-                </a:solidFill>
-                <a:latin typeface="Calibri" pitchFamily="34" charset="0"/>
-                <a:ea typeface="Calibri" pitchFamily="34" charset="-122"/>
-                <a:cs typeface="Calibri" pitchFamily="34" charset="-120"/>
-              </a:rPr>
-              <a:t>C'est   </a:t>
-            </a:r>
-            <a:pPr indent="0" marL="0">
-              <a:buNone/>
-            </a:pPr>
-            <a:r>
-              <a:rPr lang="en-US" sz="1300" dirty="0">
-                <a:solidFill>
-                  <a:srgbClr val="9DABB6"/>
-                </a:solidFill>
-                <a:latin typeface="Calibri" pitchFamily="34" charset="0"/>
-                <a:ea typeface="Calibri" pitchFamily="34" charset="-122"/>
-                <a:cs typeface="Calibri" pitchFamily="34" charset="-120"/>
-              </a:rPr>
-              <a:t>IDS aveugle sur l'OT, SIEM désactivé, aucun journal.</a:t>
-            </a:r>
-            <a:endParaRPr lang="en-US" sz="1300" dirty="0"/>
-          </a:p>
-        </p:txBody>
-      </p:sp>
-      <p:sp>
-        <p:nvSpPr>
-          <p:cNvPr id="21" name="Text 19"/>
-          <p:cNvSpPr txBox="1"/>
-          <p:nvPr/>
-        </p:nvSpPr>
-        <p:spPr>
-          <a:xfrm>
-            <a:off x="731520" y="5330952"/>
-            <a:ext cx="5010912" cy="402336"/>
-          </a:xfrm>
-          <a:prstGeom prst="rect">
-            <a:avLst/>
-          </a:prstGeom>
-          <a:noFill/>
-          <a:ln/>
-        </p:spPr>
-        <p:txBody>
-          <a:bodyPr wrap="square" lIns="0" tIns="0" rIns="0" bIns="0" rtlCol="0" anchor="t"/>
-          <a:lstStyle/>
-          <a:p>
-            <a:pPr indent="0" marL="0">
-              <a:buNone/>
-            </a:pPr>
-            <a:r>
-              <a:rPr lang="en-US" sz="1300" b="1" dirty="0">
-                <a:solidFill>
-                  <a:srgbClr val="6E7C87"/>
-                </a:solidFill>
-                <a:latin typeface="Calibri" pitchFamily="34" charset="0"/>
-                <a:ea typeface="Calibri" pitchFamily="34" charset="-122"/>
-                <a:cs typeface="Calibri" pitchFamily="34" charset="-120"/>
-              </a:rPr>
-              <a:t>Effet   </a:t>
-            </a:r>
-            <a:pPr indent="0" marL="0">
-              <a:buNone/>
-            </a:pPr>
-            <a:r>
-              <a:rPr lang="en-US" sz="1300" dirty="0">
-                <a:solidFill>
-                  <a:srgbClr val="9DABB6"/>
-                </a:solidFill>
-                <a:latin typeface="Calibri" pitchFamily="34" charset="0"/>
-                <a:ea typeface="Calibri" pitchFamily="34" charset="-122"/>
-                <a:cs typeface="Calibri" pitchFamily="34" charset="-120"/>
-              </a:rPr>
-              <a:t>L'attaque passe totalement inaperçue.</a:t>
-            </a:r>
-            <a:endParaRPr lang="en-US" sz="1300" dirty="0"/>
-          </a:p>
-        </p:txBody>
-      </p:sp>
-      <p:sp>
-        <p:nvSpPr>
-          <p:cNvPr id="22" name="Text 20"/>
-          <p:cNvSpPr txBox="1"/>
-          <p:nvPr/>
-        </p:nvSpPr>
-        <p:spPr>
-          <a:xfrm>
-            <a:off x="731520" y="5788152"/>
-            <a:ext cx="5010912" cy="384048"/>
-          </a:xfrm>
-          <a:prstGeom prst="rect">
-            <a:avLst/>
-          </a:prstGeom>
-          <a:noFill/>
-          <a:ln/>
-        </p:spPr>
-        <p:txBody>
-          <a:bodyPr wrap="square" lIns="0" tIns="0" rIns="0" bIns="0" rtlCol="0" anchor="t"/>
-          <a:lstStyle/>
-          <a:p>
-            <a:pPr indent="0" marL="0">
-              <a:buNone/>
-            </a:pPr>
-            <a:r>
               <a:rPr lang="en-US" sz="1250" b="1" dirty="0">
                 <a:solidFill>
                   <a:srgbClr val="6FBF95"/>
@@ -3106,7 +3114,7 @@
                 <a:ea typeface="Calibri" pitchFamily="34" charset="-122"/>
                 <a:cs typeface="Calibri" pitchFamily="34" charset="-120"/>
               </a:rPr>
-              <a:t>IDS étendu à l'OT + SIEM centralisé</a:t>
+              <a:t>Une sonde sur le réseau industriel + un collecteur central</a:t>
             </a:r>
             <a:endParaRPr lang="en-US" sz="1250" dirty="0"/>
           </a:p>
@@ -3120,12 +3128,12 @@
         </p:nvSpPr>
         <p:spPr>
           <a:xfrm>
-            <a:off x="6190488" y="4160520"/>
-            <a:ext cx="5468112" cy="2084832"/>
+            <a:off x="6190488" y="4059936"/>
+            <a:ext cx="5468112" cy="2011680"/>
           </a:xfrm>
           <a:prstGeom prst="roundRect">
             <a:avLst>
-              <a:gd name="adj" fmla="val 2632"/>
+              <a:gd name="adj" fmla="val 2727"/>
             </a:avLst>
           </a:prstGeom>
           <a:solidFill>
@@ -3147,8 +3155,8 @@
         </p:nvSpPr>
         <p:spPr>
           <a:xfrm>
-            <a:off x="6190488" y="4160520"/>
-            <a:ext cx="73152" cy="2084832"/>
+            <a:off x="6190488" y="4059936"/>
+            <a:ext cx="73152" cy="2011680"/>
           </a:xfrm>
           <a:prstGeom prst="rect">
             <a:avLst/>
@@ -3167,8 +3175,128 @@
         </p:nvSpPr>
         <p:spPr>
           <a:xfrm>
-            <a:off x="6419088" y="4306824"/>
-            <a:ext cx="5010912" cy="365760"/>
+            <a:off x="6428232" y="4206240"/>
+            <a:ext cx="4992624" cy="475488"/>
+          </a:xfrm>
+          <a:prstGeom prst="rect">
+            <a:avLst/>
+          </a:prstGeom>
+          <a:noFill/>
+          <a:ln/>
+        </p:spPr>
+        <p:txBody>
+          <a:bodyPr wrap="square" lIns="0" tIns="0" rIns="0" bIns="0" rtlCol="0" anchor="t"/>
+          <a:lstStyle/>
+          <a:p>
+            <a:pPr indent="0" marL="0">
+              <a:lnSpc>
+                <a:spcPct val="95000"/>
+              </a:lnSpc>
+              <a:buNone/>
+            </a:pPr>
+            <a:r>
+              <a:rPr lang="en-US" sz="1550" b="1" dirty="0">
+                <a:solidFill>
+                  <a:srgbClr val="ECF1F5"/>
+                </a:solidFill>
+                <a:latin typeface="Calibri" pitchFamily="34" charset="0"/>
+                <a:ea typeface="Calibri" pitchFamily="34" charset="-122"/>
+                <a:cs typeface="Calibri" pitchFamily="34" charset="-120"/>
+              </a:rPr>
+              <a:t>Rien n'arrête le réacteur si l'automate est piraté</a:t>
+            </a:r>
+            <a:endParaRPr lang="en-US" sz="1550" dirty="0"/>
+          </a:p>
+        </p:txBody>
+      </p:sp>
+      <p:sp>
+        <p:nvSpPr>
+          <p:cNvPr id="26" name="Text 24"/>
+          <p:cNvSpPr txBox="1"/>
+          <p:nvPr/>
+        </p:nvSpPr>
+        <p:spPr>
+          <a:xfrm>
+            <a:off x="6428232" y="4681728"/>
+            <a:ext cx="4992624" cy="182880"/>
+          </a:xfrm>
+          <a:prstGeom prst="rect">
+            <a:avLst/>
+          </a:prstGeom>
+          <a:noFill/>
+          <a:ln/>
+        </p:spPr>
+        <p:txBody>
+          <a:bodyPr wrap="square" lIns="0" tIns="0" rIns="0" bIns="0" rtlCol="0" anchor="t"/>
+          <a:lstStyle/>
+          <a:p>
+            <a:pPr indent="0" marL="0">
+              <a:buNone/>
+            </a:pPr>
+            <a:r>
+              <a:rPr lang="en-US" sz="1000" dirty="0">
+                <a:solidFill>
+                  <a:srgbClr val="E4796F"/>
+                </a:solidFill>
+                <a:latin typeface="Calibri" pitchFamily="34" charset="0"/>
+                <a:ea typeface="Calibri" pitchFamily="34" charset="-122"/>
+                <a:cs typeface="Calibri" pitchFamily="34" charset="-120"/>
+              </a:rPr>
+              <a:t>V12 — aucune sécurité indépendante</a:t>
+            </a:r>
+            <a:endParaRPr lang="en-US" sz="1000" dirty="0"/>
+          </a:p>
+        </p:txBody>
+      </p:sp>
+      <p:sp>
+        <p:nvSpPr>
+          <p:cNvPr id="27" name="Text 25"/>
+          <p:cNvSpPr txBox="1"/>
+          <p:nvPr/>
+        </p:nvSpPr>
+        <p:spPr>
+          <a:xfrm>
+            <a:off x="6428232" y="4937760"/>
+            <a:ext cx="4992624" cy="713232"/>
+          </a:xfrm>
+          <a:prstGeom prst="rect">
+            <a:avLst/>
+          </a:prstGeom>
+          <a:noFill/>
+          <a:ln/>
+        </p:spPr>
+        <p:txBody>
+          <a:bodyPr wrap="square" lIns="0" tIns="0" rIns="0" bIns="0" rtlCol="0" anchor="t"/>
+          <a:lstStyle/>
+          <a:p>
+            <a:pPr indent="0" marL="0">
+              <a:buNone/>
+            </a:pPr>
+            <a:r>
+              <a:rPr lang="en-US" sz="1350" dirty="0">
+                <a:solidFill>
+                  <a:srgbClr val="9DABB6"/>
+                </a:solidFill>
+                <a:latin typeface="Calibri" pitchFamily="34" charset="0"/>
+                <a:ea typeface="Calibri" pitchFamily="34" charset="-122"/>
+                <a:cs typeface="Calibri" pitchFamily="34" charset="-120"/>
+              </a:rPr>
+              <a:t>La seule protection contre la surpression est le programme de l'automate — justement celui qu'on a modifié.</a:t>
+            </a:r>
+            <a:endParaRPr lang="en-US" sz="1350" dirty="0"/>
+          </a:p>
+        </p:txBody>
+      </p:sp>
+      <p:sp>
+        <p:nvSpPr>
+          <p:cNvPr id="28" name="Text 26"/>
+          <p:cNvSpPr txBox="1"/>
+          <p:nvPr/>
+        </p:nvSpPr>
+        <p:spPr>
+          <a:xfrm>
+            <a:off x="6428232" y="5705856"/>
+            <a:ext cx="4992624" cy="274320"/>
           </a:xfrm>
           <a:prstGeom prst="rect">
             <a:avLst/>
@@ -3184,165 +3312,6 @@
               <a:buNone/>
             </a:pPr>
             <a:r>
-              <a:rPr lang="en-US" sz="1700" b="1" dirty="0">
-                <a:solidFill>
-                  <a:srgbClr val="E4796F"/>
-                </a:solidFill>
-                <a:latin typeface="Calibri" pitchFamily="34" charset="0"/>
-                <a:ea typeface="Calibri" pitchFamily="34" charset="-122"/>
-                <a:cs typeface="Calibri" pitchFamily="34" charset="-120"/>
-              </a:rPr>
-              <a:t>V12  </a:t>
-            </a:r>
-            <a:pPr indent="0" marL="0">
-              <a:buNone/>
-            </a:pPr>
-            <a:r>
-              <a:rPr lang="en-US" sz="1700" b="1" dirty="0">
-                <a:solidFill>
-                  <a:srgbClr val="ECF1F5"/>
-                </a:solidFill>
-                <a:latin typeface="Calibri" pitchFamily="34" charset="0"/>
-                <a:ea typeface="Calibri" pitchFamily="34" charset="-122"/>
-                <a:cs typeface="Calibri" pitchFamily="34" charset="-120"/>
-              </a:rPr>
-              <a:t>Aucune barrière de sécurité physique</a:t>
-            </a:r>
-            <a:endParaRPr lang="en-US" sz="1700" dirty="0"/>
-          </a:p>
-        </p:txBody>
-      </p:sp>
-      <p:sp>
-        <p:nvSpPr>
-          <p:cNvPr id="26" name="Text 24"/>
-          <p:cNvSpPr txBox="1"/>
-          <p:nvPr/>
-        </p:nvSpPr>
-        <p:spPr>
-          <a:xfrm>
-            <a:off x="6419088" y="4727448"/>
-            <a:ext cx="5010912" cy="603504"/>
-          </a:xfrm>
-          <a:prstGeom prst="rect">
-            <a:avLst/>
-          </a:prstGeom>
-          <a:noFill/>
-          <a:ln/>
-        </p:spPr>
-        <p:txBody>
-          <a:bodyPr wrap="square" lIns="0" tIns="0" rIns="0" bIns="0" rtlCol="0" anchor="t"/>
-          <a:lstStyle/>
-          <a:p>
-            <a:pPr indent="0" marL="0">
-              <a:buNone/>
-            </a:pPr>
-            <a:r>
-              <a:rPr lang="en-US" sz="1300" b="1" dirty="0">
-                <a:solidFill>
-                  <a:srgbClr val="6E7C87"/>
-                </a:solidFill>
-                <a:latin typeface="Calibri" pitchFamily="34" charset="0"/>
-                <a:ea typeface="Calibri" pitchFamily="34" charset="-122"/>
-                <a:cs typeface="Calibri" pitchFamily="34" charset="-120"/>
-              </a:rPr>
-              <a:t>C'est   </a:t>
-            </a:r>
-            <a:pPr indent="0" marL="0">
-              <a:buNone/>
-            </a:pPr>
-            <a:r>
-              <a:rPr lang="en-US" sz="1300" dirty="0">
-                <a:solidFill>
-                  <a:srgbClr val="9DABB6"/>
-                </a:solidFill>
-                <a:latin typeface="Calibri" pitchFamily="34" charset="0"/>
-                <a:ea typeface="Calibri" pitchFamily="34" charset="-122"/>
-                <a:cs typeface="Calibri" pitchFamily="34" charset="-120"/>
-              </a:rPr>
-              <a:t>La seule protection est le programme de l'automate — celui qu'on pirate.</a:t>
-            </a:r>
-            <a:endParaRPr lang="en-US" sz="1300" dirty="0"/>
-          </a:p>
-        </p:txBody>
-      </p:sp>
-      <p:sp>
-        <p:nvSpPr>
-          <p:cNvPr id="27" name="Text 25"/>
-          <p:cNvSpPr txBox="1"/>
-          <p:nvPr/>
-        </p:nvSpPr>
-        <p:spPr>
-          <a:xfrm>
-            <a:off x="6419088" y="5330952"/>
-            <a:ext cx="5010912" cy="402336"/>
-          </a:xfrm>
-          <a:prstGeom prst="rect">
-            <a:avLst/>
-          </a:prstGeom>
-          <a:noFill/>
-          <a:ln/>
-        </p:spPr>
-        <p:txBody>
-          <a:bodyPr wrap="square" lIns="0" tIns="0" rIns="0" bIns="0" rtlCol="0" anchor="t"/>
-          <a:lstStyle/>
-          <a:p>
-            <a:pPr indent="0" marL="0">
-              <a:buNone/>
-            </a:pPr>
-            <a:r>
-              <a:rPr lang="en-US" sz="1300" b="1" dirty="0">
-                <a:solidFill>
-                  <a:srgbClr val="6E7C87"/>
-                </a:solidFill>
-                <a:latin typeface="Calibri" pitchFamily="34" charset="0"/>
-                <a:ea typeface="Calibri" pitchFamily="34" charset="-122"/>
-                <a:cs typeface="Calibri" pitchFamily="34" charset="-120"/>
-              </a:rPr>
-              <a:t>Effet   </a:t>
-            </a:r>
-            <a:pPr indent="0" marL="0">
-              <a:buNone/>
-            </a:pPr>
-            <a:r>
-              <a:rPr lang="en-US" sz="1300" dirty="0">
-                <a:solidFill>
-                  <a:srgbClr val="9DABB6"/>
-                </a:solidFill>
-                <a:latin typeface="Calibri" pitchFamily="34" charset="0"/>
-                <a:ea typeface="Calibri" pitchFamily="34" charset="-122"/>
-                <a:cs typeface="Calibri" pitchFamily="34" charset="-120"/>
-              </a:rPr>
-              <a:t>Rien n'arrête l'emballement : explosion.</a:t>
-            </a:r>
-            <a:endParaRPr lang="en-US" sz="1300" dirty="0"/>
-          </a:p>
-        </p:txBody>
-      </p:sp>
-      <p:sp>
-        <p:nvSpPr>
-          <p:cNvPr id="28" name="Text 26"/>
-          <p:cNvSpPr txBox="1"/>
-          <p:nvPr/>
-        </p:nvSpPr>
-        <p:spPr>
-          <a:xfrm>
-            <a:off x="6419088" y="5788152"/>
-            <a:ext cx="5010912" cy="384048"/>
-          </a:xfrm>
-          <a:prstGeom prst="rect">
-            <a:avLst/>
-          </a:prstGeom>
-          <a:noFill/>
-          <a:ln/>
-        </p:spPr>
-        <p:txBody>
-          <a:bodyPr wrap="square" lIns="0" tIns="0" rIns="0" bIns="0" rtlCol="0" anchor="t"/>
-          <a:lstStyle/>
-          <a:p>
-            <a:pPr indent="0" marL="0">
-              <a:buNone/>
-            </a:pPr>
-            <a:r>
               <a:rPr lang="en-US" sz="1250" b="1" dirty="0">
                 <a:solidFill>
                   <a:srgbClr val="6FBF95"/>
@@ -3365,7 +3334,7 @@
                 <a:ea typeface="Calibri" pitchFamily="34" charset="-122"/>
                 <a:cs typeface="Calibri" pitchFamily="34" charset="-120"/>
               </a:rPr>
-              <a:t>Barrière SIL 2 indépendante (interlock câblé)</a:t>
+              <a:t>Une sécurité câblée qui purge toute seule, hors réseau</a:t>
             </a:r>
             <a:endParaRPr lang="en-US" sz="1250" dirty="0"/>
           </a:p>
@@ -3404,7 +3373,7 @@
                 <a:ea typeface="Calibri" pitchFamily="34" charset="-122"/>
                 <a:cs typeface="Calibri" pitchFamily="34" charset="-120"/>
               </a:rPr>
-              <a:t>Vulnérabilités · 2/3 — Logiques &amp; logicielles</a:t>
+              <a:t>Vulnérabilités · 2/3 — Failles informatiques</a:t>
             </a:r>
             <a:pPr indent="0" marL="0">
               <a:buNone/>
@@ -3418,7 +3387,7 @@
                 <a:ea typeface="Calibri" pitchFamily="34" charset="-122"/>
                 <a:cs typeface="Calibri" pitchFamily="34" charset="-120"/>
               </a:rPr>
-              <a:t>        Chaque carte : le problème, l'effet, le correctif</a:t>
+              <a:t>        Chaque carte : le problème en clair, puis le correctif</a:t>
             </a:r>
             <a:endParaRPr lang="en-US" sz="950" dirty="0"/>
           </a:p>
@@ -3546,7 +3515,7 @@
                 <a:ea typeface="Calibri" pitchFamily="34" charset="-122"/>
                 <a:cs typeface="Calibri" pitchFamily="34" charset="-120"/>
               </a:rPr>
-              <a:t>   LA CHAÎNE, EN UNE PHRASE</a:t>
+              <a:t>   L'ENCHAÎNEMENT, EN UNE PHRASE</a:t>
             </a:r>
             <a:endParaRPr lang="en-US" sz="1100" dirty="0"/>
           </a:p>
@@ -3588,7 +3557,7 @@
                 <a:ea typeface="Cambria" pitchFamily="34" charset="-122"/>
                 <a:cs typeface="Cambria" pitchFamily="34" charset="-120"/>
               </a:rPr>
-              <a:t>Chaque maillon coupé casse l'attaque</a:t>
+              <a:t>Chaque maillon coupé fait échouer l'attaque</a:t>
             </a:r>
             <a:endParaRPr lang="en-US" sz="3200" dirty="0"/>
           </a:p>
@@ -3602,12 +3571,12 @@
         </p:nvSpPr>
         <p:spPr>
           <a:xfrm>
-            <a:off x="502920" y="2148840"/>
-            <a:ext cx="2651760" cy="1051560"/>
+            <a:off x="502920" y="2103120"/>
+            <a:ext cx="2651760" cy="1234440"/>
           </a:xfrm>
           <a:prstGeom prst="roundRect">
             <a:avLst>
-              <a:gd name="adj" fmla="val 5217"/>
+              <a:gd name="adj" fmla="val 4444"/>
             </a:avLst>
           </a:prstGeom>
           <a:solidFill>
@@ -3629,8 +3598,8 @@
         </p:nvSpPr>
         <p:spPr>
           <a:xfrm>
-            <a:off x="502920" y="2313432"/>
-            <a:ext cx="2651760" cy="365760"/>
+            <a:off x="594360" y="2267712"/>
+            <a:ext cx="2468880" cy="329184"/>
           </a:xfrm>
           <a:prstGeom prst="rect">
             <a:avLst/>
@@ -3646,7 +3615,7 @@
               <a:buNone/>
             </a:pPr>
             <a:r>
-              <a:rPr lang="en-US" sz="1900" b="1" dirty="0">
+              <a:rPr lang="en-US" sz="1700" b="1" dirty="0">
                 <a:solidFill>
                   <a:srgbClr val="E0A64A"/>
                 </a:solidFill>
@@ -3654,9 +3623,9 @@
                 <a:ea typeface="Cambria" pitchFamily="34" charset="-122"/>
                 <a:cs typeface="Cambria" pitchFamily="34" charset="-120"/>
               </a:rPr>
-              <a:t>PHYSIQUE</a:t>
-            </a:r>
-            <a:endParaRPr lang="en-US" sz="1900" dirty="0"/>
+              <a:t>ON ENTRE</a:t>
+            </a:r>
+            <a:endParaRPr lang="en-US" sz="1700" dirty="0"/>
           </a:p>
         </p:txBody>
       </p:sp>
@@ -3668,8 +3637,8 @@
         </p:nvSpPr>
         <p:spPr>
           <a:xfrm>
-            <a:off x="594360" y="2697480"/>
-            <a:ext cx="2468880" cy="411480"/>
+            <a:off x="640080" y="2651760"/>
+            <a:ext cx="2377440" cy="566928"/>
           </a:xfrm>
           <a:prstGeom prst="rect">
             <a:avLst/>
@@ -3685,7 +3654,7 @@
               <a:buNone/>
             </a:pPr>
             <a:r>
-              <a:rPr lang="en-US" sz="1250" dirty="0">
+              <a:rPr lang="en-US" sz="1200" dirty="0">
                 <a:solidFill>
                   <a:srgbClr val="9DABB6"/>
                 </a:solidFill>
@@ -3693,9 +3662,9 @@
                 <a:ea typeface="Calibri" pitchFamily="34" charset="-122"/>
                 <a:cs typeface="Calibri" pitchFamily="34" charset="-120"/>
               </a:rPr>
-              <a:t>accès + mots de passe</a:t>
-            </a:r>
-            <a:endParaRPr lang="en-US" sz="1250" dirty="0"/>
+              <a:t>failles physiques : accès et mots de passe</a:t>
+            </a:r>
+            <a:endParaRPr lang="en-US" sz="1200" dirty="0"/>
           </a:p>
         </p:txBody>
       </p:sp>
@@ -3707,8 +3676,8 @@
         </p:nvSpPr>
         <p:spPr>
           <a:xfrm>
-            <a:off x="3154680" y="2148840"/>
-            <a:ext cx="320040" cy="1051560"/>
+            <a:off x="3154680" y="2103120"/>
+            <a:ext cx="320040" cy="1234440"/>
           </a:xfrm>
           <a:prstGeom prst="rect">
             <a:avLst/>
@@ -3746,12 +3715,12 @@
         </p:nvSpPr>
         <p:spPr>
           <a:xfrm>
-            <a:off x="3474720" y="2148840"/>
-            <a:ext cx="2651760" cy="1051560"/>
+            <a:off x="3474720" y="2103120"/>
+            <a:ext cx="2651760" cy="1234440"/>
           </a:xfrm>
           <a:prstGeom prst="roundRect">
             <a:avLst>
-              <a:gd name="adj" fmla="val 5217"/>
+              <a:gd name="adj" fmla="val 4444"/>
             </a:avLst>
           </a:prstGeom>
           <a:solidFill>
@@ -3773,8 +3742,8 @@
         </p:nvSpPr>
         <p:spPr>
           <a:xfrm>
-            <a:off x="3474720" y="2313432"/>
-            <a:ext cx="2651760" cy="365760"/>
+            <a:off x="3566160" y="2267712"/>
+            <a:ext cx="2468880" cy="329184"/>
           </a:xfrm>
           <a:prstGeom prst="rect">
             <a:avLst/>
@@ -3790,7 +3759,7 @@
               <a:buNone/>
             </a:pPr>
             <a:r>
-              <a:rPr lang="en-US" sz="1900" b="1" dirty="0">
+              <a:rPr lang="en-US" sz="1700" b="1" dirty="0">
                 <a:solidFill>
                   <a:srgbClr val="E4796F"/>
                 </a:solidFill>
@@ -3798,9 +3767,9 @@
                 <a:ea typeface="Cambria" pitchFamily="34" charset="-122"/>
                 <a:cs typeface="Cambria" pitchFamily="34" charset="-120"/>
               </a:rPr>
-              <a:t>V1 + V3</a:t>
-            </a:r>
-            <a:endParaRPr lang="en-US" sz="1900" dirty="0"/>
+              <a:t>ON COMMANDE</a:t>
+            </a:r>
+            <a:endParaRPr lang="en-US" sz="1700" dirty="0"/>
           </a:p>
         </p:txBody>
       </p:sp>
@@ -3812,8 +3781,8 @@
         </p:nvSpPr>
         <p:spPr>
           <a:xfrm>
-            <a:off x="3566160" y="2697480"/>
-            <a:ext cx="2468880" cy="411480"/>
+            <a:off x="3611880" y="2651760"/>
+            <a:ext cx="2377440" cy="566928"/>
           </a:xfrm>
           <a:prstGeom prst="rect">
             <a:avLst/>
@@ -3829,7 +3798,7 @@
               <a:buNone/>
             </a:pPr>
             <a:r>
-              <a:rPr lang="en-US" sz="1250" dirty="0">
+              <a:rPr lang="en-US" sz="1200" dirty="0">
                 <a:solidFill>
                   <a:srgbClr val="9DABB6"/>
                 </a:solidFill>
@@ -3837,9 +3806,9 @@
                 <a:ea typeface="Calibri" pitchFamily="34" charset="-122"/>
                 <a:cs typeface="Calibri" pitchFamily="34" charset="-120"/>
               </a:rPr>
-              <a:t>on atteint l'automate</a:t>
-            </a:r>
-            <a:endParaRPr lang="en-US" sz="1250" dirty="0"/>
+              <a:t>le filtre est ouvert, les ordres non vérifiés</a:t>
+            </a:r>
+            <a:endParaRPr lang="en-US" sz="1200" dirty="0"/>
           </a:p>
         </p:txBody>
       </p:sp>
@@ -3851,8 +3820,8 @@
         </p:nvSpPr>
         <p:spPr>
           <a:xfrm>
-            <a:off x="6126480" y="2148840"/>
-            <a:ext cx="320040" cy="1051560"/>
+            <a:off x="6126480" y="2103120"/>
+            <a:ext cx="320040" cy="1234440"/>
           </a:xfrm>
           <a:prstGeom prst="rect">
             <a:avLst/>
@@ -3890,12 +3859,12 @@
         </p:nvSpPr>
         <p:spPr>
           <a:xfrm>
-            <a:off x="6446520" y="2148840"/>
-            <a:ext cx="2651760" cy="1051560"/>
+            <a:off x="6446520" y="2103120"/>
+            <a:ext cx="2651760" cy="1234440"/>
           </a:xfrm>
           <a:prstGeom prst="roundRect">
             <a:avLst>
-              <a:gd name="adj" fmla="val 5217"/>
+              <a:gd name="adj" fmla="val 4444"/>
             </a:avLst>
           </a:prstGeom>
           <a:solidFill>
@@ -3917,8 +3886,8 @@
         </p:nvSpPr>
         <p:spPr>
           <a:xfrm>
-            <a:off x="6446520" y="2313432"/>
-            <a:ext cx="2651760" cy="365760"/>
+            <a:off x="6537960" y="2267712"/>
+            <a:ext cx="2468880" cy="329184"/>
           </a:xfrm>
           <a:prstGeom prst="rect">
             <a:avLst/>
@@ -3934,7 +3903,7 @@
               <a:buNone/>
             </a:pPr>
             <a:r>
-              <a:rPr lang="en-US" sz="1900" b="1" dirty="0">
+              <a:rPr lang="en-US" sz="1700" b="1" dirty="0">
                 <a:solidFill>
                   <a:srgbClr val="E0A64A"/>
                 </a:solidFill>
@@ -3942,9 +3911,9 @@
                 <a:ea typeface="Cambria" pitchFamily="34" charset="-122"/>
                 <a:cs typeface="Cambria" pitchFamily="34" charset="-120"/>
               </a:rPr>
-              <a:t>V7 · V8</a:t>
-            </a:r>
-            <a:endParaRPr lang="en-US" sz="1900" dirty="0"/>
+              <a:t>PERSONNE NE VOIT</a:t>
+            </a:r>
+            <a:endParaRPr lang="en-US" sz="1700" dirty="0"/>
           </a:p>
         </p:txBody>
       </p:sp>
@@ -3956,8 +3925,8 @@
         </p:nvSpPr>
         <p:spPr>
           <a:xfrm>
-            <a:off x="6537960" y="2697480"/>
-            <a:ext cx="2468880" cy="411480"/>
+            <a:off x="6583680" y="2651760"/>
+            <a:ext cx="2377440" cy="566928"/>
           </a:xfrm>
           <a:prstGeom prst="rect">
             <a:avLst/>
@@ -3973,7 +3942,7 @@
               <a:buNone/>
             </a:pPr>
             <a:r>
-              <a:rPr lang="en-US" sz="1250" dirty="0">
+              <a:rPr lang="en-US" sz="1200" dirty="0">
                 <a:solidFill>
                   <a:srgbClr val="9DABB6"/>
                 </a:solidFill>
@@ -3981,9 +3950,9 @@
                 <a:ea typeface="Calibri" pitchFamily="34" charset="-122"/>
                 <a:cs typeface="Calibri" pitchFamily="34" charset="-120"/>
               </a:rPr>
-              <a:t>personne ne voit rien</a:t>
-            </a:r>
-            <a:endParaRPr lang="en-US" sz="1250" dirty="0"/>
+              <a:t>aucune surveillance, aucun historique</a:t>
+            </a:r>
+            <a:endParaRPr lang="en-US" sz="1200" dirty="0"/>
           </a:p>
         </p:txBody>
       </p:sp>
@@ -3995,8 +3964,8 @@
         </p:nvSpPr>
         <p:spPr>
           <a:xfrm>
-            <a:off x="9098280" y="2148840"/>
-            <a:ext cx="320040" cy="1051560"/>
+            <a:off x="9098280" y="2103120"/>
+            <a:ext cx="320040" cy="1234440"/>
           </a:xfrm>
           <a:prstGeom prst="rect">
             <a:avLst/>
@@ -4034,12 +4003,12 @@
         </p:nvSpPr>
         <p:spPr>
           <a:xfrm>
-            <a:off x="9418320" y="2148840"/>
-            <a:ext cx="2651760" cy="1051560"/>
+            <a:off x="9418320" y="2103120"/>
+            <a:ext cx="2651760" cy="1234440"/>
           </a:xfrm>
           <a:prstGeom prst="roundRect">
             <a:avLst>
-              <a:gd name="adj" fmla="val 5217"/>
+              <a:gd name="adj" fmla="val 4444"/>
             </a:avLst>
           </a:prstGeom>
           <a:solidFill>
@@ -4061,8 +4030,8 @@
         </p:nvSpPr>
         <p:spPr>
           <a:xfrm>
-            <a:off x="9418320" y="2313432"/>
-            <a:ext cx="2651760" cy="365760"/>
+            <a:off x="9509760" y="2267712"/>
+            <a:ext cx="2468880" cy="329184"/>
           </a:xfrm>
           <a:prstGeom prst="rect">
             <a:avLst/>
@@ -4078,7 +4047,7 @@
               <a:buNone/>
             </a:pPr>
             <a:r>
-              <a:rPr lang="en-US" sz="1900" b="1" dirty="0">
+              <a:rPr lang="en-US" sz="1700" b="1" dirty="0">
                 <a:solidFill>
                   <a:srgbClr val="E4796F"/>
                 </a:solidFill>
@@ -4086,9 +4055,9 @@
                 <a:ea typeface="Cambria" pitchFamily="34" charset="-122"/>
                 <a:cs typeface="Cambria" pitchFamily="34" charset="-120"/>
               </a:rPr>
-              <a:t>V12</a:t>
-            </a:r>
-            <a:endParaRPr lang="en-US" sz="1900" dirty="0"/>
+              <a:t>ÇA EXPLOSE</a:t>
+            </a:r>
+            <a:endParaRPr lang="en-US" sz="1700" dirty="0"/>
           </a:p>
         </p:txBody>
       </p:sp>
@@ -4100,8 +4069,8 @@
         </p:nvSpPr>
         <p:spPr>
           <a:xfrm>
-            <a:off x="9509760" y="2697480"/>
-            <a:ext cx="2468880" cy="411480"/>
+            <a:off x="9555480" y="2651760"/>
+            <a:ext cx="2377440" cy="566928"/>
           </a:xfrm>
           <a:prstGeom prst="rect">
             <a:avLst/>
@@ -4117,7 +4086,7 @@
               <a:buNone/>
             </a:pPr>
             <a:r>
-              <a:rPr lang="en-US" sz="1250" dirty="0">
+              <a:rPr lang="en-US" sz="1200" dirty="0">
                 <a:solidFill>
                   <a:srgbClr val="9DABB6"/>
                 </a:solidFill>
@@ -4125,9 +4094,9 @@
                 <a:ea typeface="Calibri" pitchFamily="34" charset="-122"/>
                 <a:cs typeface="Calibri" pitchFamily="34" charset="-120"/>
               </a:rPr>
-              <a:t>→ explosion</a:t>
-            </a:r>
-            <a:endParaRPr lang="en-US" sz="1250" dirty="0"/>
+              <a:t>aucune sécurité indépendante de l'automate</a:t>
+            </a:r>
+            <a:endParaRPr lang="en-US" sz="1200" dirty="0"/>
           </a:p>
         </p:txBody>
       </p:sp>
@@ -4139,12 +4108,12 @@
         </p:nvSpPr>
         <p:spPr>
           <a:xfrm>
-            <a:off x="502920" y="3703320"/>
-            <a:ext cx="11155680" cy="1417320"/>
+            <a:off x="502920" y="3794760"/>
+            <a:ext cx="11155680" cy="1371600"/>
           </a:xfrm>
           <a:prstGeom prst="roundRect">
             <a:avLst>
-              <a:gd name="adj" fmla="val 3871"/>
+              <a:gd name="adj" fmla="val 4000"/>
             </a:avLst>
           </a:prstGeom>
           <a:solidFill>
@@ -4166,8 +4135,8 @@
         </p:nvSpPr>
         <p:spPr>
           <a:xfrm>
-            <a:off x="777240" y="3886200"/>
-            <a:ext cx="10607040" cy="1051560"/>
+            <a:off x="777240" y="3977640"/>
+            <a:ext cx="10607040" cy="1005840"/>
           </a:xfrm>
           <a:prstGeom prst="rect">
             <a:avLst/>
@@ -4211,7 +4180,7 @@
                 <a:ea typeface="Calibri" pitchFamily="34" charset="-122"/>
                 <a:cs typeface="Calibri" pitchFamily="34" charset="-120"/>
               </a:rPr>
-              <a:t>le pare-feu ouvert (V1) et le Modbus en clair (V3)</a:t>
+              <a:t>le filtre ouvert et les ordres non vérifiés</a:t>
             </a:r>
             <a:pPr indent="0" marL="0">
               <a:lnSpc>
@@ -4228,7 +4197,7 @@
                 <a:ea typeface="Calibri" pitchFamily="34" charset="-122"/>
                 <a:cs typeface="Calibri" pitchFamily="34" charset="-120"/>
               </a:rPr>
-              <a:t> mènent librement à l'automate → </a:t>
+              <a:t> mènent jusqu'à l'automate → </a:t>
             </a:r>
             <a:pPr indent="0" marL="0">
               <a:lnSpc>
@@ -4245,7 +4214,7 @@
                 <a:ea typeface="Calibri" pitchFamily="34" charset="-122"/>
                 <a:cs typeface="Calibri" pitchFamily="34" charset="-120"/>
               </a:rPr>
-              <a:t>l'absence de détection (V7·V8)</a:t>
+              <a:t>l'absence de surveillance</a:t>
             </a:r>
             <a:pPr indent="0" marL="0">
               <a:lnSpc>
@@ -4279,7 +4248,7 @@
                 <a:ea typeface="Calibri" pitchFamily="34" charset="-122"/>
                 <a:cs typeface="Calibri" pitchFamily="34" charset="-120"/>
               </a:rPr>
-              <a:t>l'absence de barrière (V12)</a:t>
+              <a:t>l'absence de sécurité indépendante</a:t>
             </a:r>
             <a:pPr indent="0" marL="0">
               <a:lnSpc>
@@ -4310,7 +4279,7 @@
         </p:nvSpPr>
         <p:spPr>
           <a:xfrm>
-            <a:off x="502920" y="5440680"/>
+            <a:off x="502920" y="5486400"/>
             <a:ext cx="11155680" cy="457200"/>
           </a:xfrm>
           <a:prstGeom prst="rect">
@@ -4335,7 +4304,7 @@
                 <a:ea typeface="Calibri" pitchFamily="34" charset="-122"/>
                 <a:cs typeface="Calibri" pitchFamily="34" charset="-120"/>
               </a:rPr>
-              <a:t>La barrière V12 est le dernier rempart : </a:t>
+              <a:t>La sécurité câblée est le dernier rempart : </a:t>
             </a:r>
             <a:pPr indent="0" marL="0">
               <a:buNone/>
@@ -4349,7 +4318,7 @@
                 <a:ea typeface="Calibri" pitchFamily="34" charset="-122"/>
                 <a:cs typeface="Calibri" pitchFamily="34" charset="-120"/>
               </a:rPr>
-              <a:t>elle arrête le procédé même si tout le numérique est compromis.</a:t>
+              <a:t>elle arrête le réacteur même si toute l'informatique est piratée.</a:t>
             </a:r>
             <a:endParaRPr lang="en-US" sz="1400" dirty="0"/>
           </a:p>
@@ -4402,7 +4371,7 @@
                 <a:ea typeface="Calibri" pitchFamily="34" charset="-122"/>
                 <a:cs typeface="Calibri" pitchFamily="34" charset="-120"/>
               </a:rPr>
-              <a:t>        Physique → réseau → détection → sûreté</a:t>
+              <a:t>        On entre → on commande → personne ne voit → ça explose</a:t>
             </a:r>
             <a:endParaRPr lang="en-US" sz="950" dirty="0"/>
           </a:p>

</xml_diff>